<commit_message>
Gera PDF do balanco online com tamanhos do template PPT.
</commit_message>
<xml_diff>
--- a/public/templates/Modelo_de_PPT.pptx
+++ b/public/templates/Modelo_de_PPT.pptx
@@ -1,21 +1,21 @@
 
 <file path=ppt/presentation.xml><?xml version="1.0" encoding="utf-8"?>
-<p:presentation xmlns:a="http://schemas.openxmlformats.org/drawingml/2006/main" xmlns:r="http://schemas.openxmlformats.org/officeDocument/2006/relationships" xmlns:p="http://schemas.openxmlformats.org/presentationml/2006/main" saveSubsetFonts="1" autoCompressPictures="0">
+<p:presentation xmlns:a="http://schemas.openxmlformats.org/drawingml/2006/main" xmlns:r="http://schemas.openxmlformats.org/officeDocument/2006/relationships" xmlns:p="http://schemas.openxmlformats.org/presentationml/2006/main" saveSubsetFonts="1">
   <p:sldMasterIdLst>
     <p:sldMasterId id="2147483648" r:id="rId1"/>
   </p:sldMasterIdLst>
   <p:sldIdLst>
-    <p:sldId id="256" r:id="rId7"/>
-    <p:sldId id="257" r:id="rId8"/>
-    <p:sldId id="258" r:id="rId9"/>
+    <p:sldId id="256" r:id="rId2"/>
+    <p:sldId id="257" r:id="rId3"/>
+    <p:sldId id="258" r:id="rId4"/>
   </p:sldIdLst>
-  <p:sldSz cx="9144000" cy="6858000" type="screen4x3"/>
+  <p:sldSz cx="12192000" cy="6858000"/>
   <p:notesSz cx="6858000" cy="9144000"/>
   <p:defaultTextStyle>
     <a:defPPr>
-      <a:defRPr lang="en-US"/>
+      <a:defRPr lang="pt-BR"/>
     </a:defPPr>
-    <a:lvl1pPr marL="0" algn="l" defTabSz="457200" rtl="0" eaLnBrk="1" latinLnBrk="0" hangingPunct="1">
+    <a:lvl1pPr marL="0" algn="l" defTabSz="914400" rtl="0" eaLnBrk="1" latinLnBrk="0" hangingPunct="1">
       <a:defRPr sz="1800" kern="1200">
         <a:solidFill>
           <a:schemeClr val="tx1"/>
@@ -25,7 +25,7 @@
         <a:cs typeface="+mn-cs"/>
       </a:defRPr>
     </a:lvl1pPr>
-    <a:lvl2pPr marL="457200" algn="l" defTabSz="457200" rtl="0" eaLnBrk="1" latinLnBrk="0" hangingPunct="1">
+    <a:lvl2pPr marL="457200" algn="l" defTabSz="914400" rtl="0" eaLnBrk="1" latinLnBrk="0" hangingPunct="1">
       <a:defRPr sz="1800" kern="1200">
         <a:solidFill>
           <a:schemeClr val="tx1"/>
@@ -35,7 +35,7 @@
         <a:cs typeface="+mn-cs"/>
       </a:defRPr>
     </a:lvl2pPr>
-    <a:lvl3pPr marL="914400" algn="l" defTabSz="457200" rtl="0" eaLnBrk="1" latinLnBrk="0" hangingPunct="1">
+    <a:lvl3pPr marL="914400" algn="l" defTabSz="914400" rtl="0" eaLnBrk="1" latinLnBrk="0" hangingPunct="1">
       <a:defRPr sz="1800" kern="1200">
         <a:solidFill>
           <a:schemeClr val="tx1"/>
@@ -45,7 +45,7 @@
         <a:cs typeface="+mn-cs"/>
       </a:defRPr>
     </a:lvl3pPr>
-    <a:lvl4pPr marL="1371600" algn="l" defTabSz="457200" rtl="0" eaLnBrk="1" latinLnBrk="0" hangingPunct="1">
+    <a:lvl4pPr marL="1371600" algn="l" defTabSz="914400" rtl="0" eaLnBrk="1" latinLnBrk="0" hangingPunct="1">
       <a:defRPr sz="1800" kern="1200">
         <a:solidFill>
           <a:schemeClr val="tx1"/>
@@ -55,7 +55,7 @@
         <a:cs typeface="+mn-cs"/>
       </a:defRPr>
     </a:lvl4pPr>
-    <a:lvl5pPr marL="1828800" algn="l" defTabSz="457200" rtl="0" eaLnBrk="1" latinLnBrk="0" hangingPunct="1">
+    <a:lvl5pPr marL="1828800" algn="l" defTabSz="914400" rtl="0" eaLnBrk="1" latinLnBrk="0" hangingPunct="1">
       <a:defRPr sz="1800" kern="1200">
         <a:solidFill>
           <a:schemeClr val="tx1"/>
@@ -65,7 +65,7 @@
         <a:cs typeface="+mn-cs"/>
       </a:defRPr>
     </a:lvl5pPr>
-    <a:lvl6pPr marL="2286000" algn="l" defTabSz="457200" rtl="0" eaLnBrk="1" latinLnBrk="0" hangingPunct="1">
+    <a:lvl6pPr marL="2286000" algn="l" defTabSz="914400" rtl="0" eaLnBrk="1" latinLnBrk="0" hangingPunct="1">
       <a:defRPr sz="1800" kern="1200">
         <a:solidFill>
           <a:schemeClr val="tx1"/>
@@ -75,7 +75,7 @@
         <a:cs typeface="+mn-cs"/>
       </a:defRPr>
     </a:lvl6pPr>
-    <a:lvl7pPr marL="2743200" algn="l" defTabSz="457200" rtl="0" eaLnBrk="1" latinLnBrk="0" hangingPunct="1">
+    <a:lvl7pPr marL="2743200" algn="l" defTabSz="914400" rtl="0" eaLnBrk="1" latinLnBrk="0" hangingPunct="1">
       <a:defRPr sz="1800" kern="1200">
         <a:solidFill>
           <a:schemeClr val="tx1"/>
@@ -85,7 +85,7 @@
         <a:cs typeface="+mn-cs"/>
       </a:defRPr>
     </a:lvl7pPr>
-    <a:lvl8pPr marL="3200400" algn="l" defTabSz="457200" rtl="0" eaLnBrk="1" latinLnBrk="0" hangingPunct="1">
+    <a:lvl8pPr marL="3200400" algn="l" defTabSz="914400" rtl="0" eaLnBrk="1" latinLnBrk="0" hangingPunct="1">
       <a:defRPr sz="1800" kern="1200">
         <a:solidFill>
           <a:schemeClr val="tx1"/>
@@ -95,7 +95,7 @@
         <a:cs typeface="+mn-cs"/>
       </a:defRPr>
     </a:lvl8pPr>
-    <a:lvl9pPr marL="3657600" algn="l" defTabSz="457200" rtl="0" eaLnBrk="1" latinLnBrk="0" hangingPunct="1">
+    <a:lvl9pPr marL="3657600" algn="l" defTabSz="914400" rtl="0" eaLnBrk="1" latinLnBrk="0" hangingPunct="1">
       <a:defRPr sz="1800" kern="1200">
         <a:solidFill>
           <a:schemeClr val="tx1"/>
@@ -111,7 +111,7 @@
 
 <file path=ppt/slideLayouts/slideLayout1.xml><?xml version="1.0" encoding="utf-8"?>
 <p:sldLayout xmlns:a="http://schemas.openxmlformats.org/drawingml/2006/main" xmlns:r="http://schemas.openxmlformats.org/officeDocument/2006/relationships" xmlns:p="http://schemas.openxmlformats.org/presentationml/2006/main" type="title" preserve="1">
-  <p:cSld name="Title Slide">
+  <p:cSld name="Slide de Título">
     <p:spTree>
       <p:nvGrpSpPr>
         <p:cNvPr id="1" name=""/>
@@ -128,7 +128,13 @@
       </p:grpSpPr>
       <p:sp>
         <p:nvSpPr>
-          <p:cNvPr id="2" name="Title 1"/>
+          <p:cNvPr id="2" name="Título 1">
+            <a:extLst>
+              <a:ext uri="{FF2B5EF4-FFF2-40B4-BE49-F238E27FC236}">
+                <a16:creationId xmlns:a16="http://schemas.microsoft.com/office/drawing/2014/main" id="{DBBD66BE-55A4-B879-FB07-769233EBB829}"/>
+              </a:ext>
+            </a:extLst>
+          </p:cNvPr>
           <p:cNvSpPr>
             <a:spLocks noGrp="1"/>
           </p:cNvSpPr>
@@ -138,25 +144,34 @@
         </p:nvSpPr>
         <p:spPr>
           <a:xfrm>
-            <a:off x="685800" y="2130425"/>
-            <a:ext cx="7772400" cy="1470025"/>
+            <a:off x="1524000" y="1122363"/>
+            <a:ext cx="9144000" cy="2387600"/>
           </a:xfrm>
         </p:spPr>
         <p:txBody>
-          <a:bodyPr/>
-          <a:lstStyle/>
-          <a:p>
-            <a:r>
-              <a:rPr lang="en-US" smtClean="0"/>
-              <a:t>Click to edit Master title style</a:t>
-            </a:r>
-            <a:endParaRPr lang="en-US"/>
-          </a:p>
-        </p:txBody>
-      </p:sp>
-      <p:sp>
-        <p:nvSpPr>
-          <p:cNvPr id="3" name="Subtitle 2"/>
+          <a:bodyPr anchor="b"/>
+          <a:lstStyle>
+            <a:lvl1pPr algn="ctr">
+              <a:defRPr sz="6000"/>
+            </a:lvl1pPr>
+          </a:lstStyle>
+          <a:p>
+            <a:r>
+              <a:rPr lang="pt-BR"/>
+              <a:t>Clique para editar o título Mestre</a:t>
+            </a:r>
+          </a:p>
+        </p:txBody>
+      </p:sp>
+      <p:sp>
+        <p:nvSpPr>
+          <p:cNvPr id="3" name="Subtítulo 2">
+            <a:extLst>
+              <a:ext uri="{FF2B5EF4-FFF2-40B4-BE49-F238E27FC236}">
+                <a16:creationId xmlns:a16="http://schemas.microsoft.com/office/drawing/2014/main" id="{76BE8FC7-A500-EF9C-D926-188140682186}"/>
+              </a:ext>
+            </a:extLst>
+          </p:cNvPr>
           <p:cNvSpPr>
             <a:spLocks noGrp="1"/>
           </p:cNvSpPr>
@@ -166,8 +181,8 @@
         </p:nvSpPr>
         <p:spPr>
           <a:xfrm>
-            <a:off x="1371600" y="3886200"/>
-            <a:ext cx="6400800" cy="1752600"/>
+            <a:off x="1524000" y="3602038"/>
+            <a:ext cx="9144000" cy="1655762"/>
           </a:xfrm>
         </p:spPr>
         <p:txBody>
@@ -175,107 +190,58 @@
           <a:lstStyle>
             <a:lvl1pPr marL="0" indent="0" algn="ctr">
               <a:buNone/>
-              <a:defRPr>
-                <a:solidFill>
-                  <a:schemeClr val="tx1">
-                    <a:tint val="75000"/>
-                  </a:schemeClr>
-                </a:solidFill>
-              </a:defRPr>
+              <a:defRPr sz="2400"/>
             </a:lvl1pPr>
             <a:lvl2pPr marL="457200" indent="0" algn="ctr">
               <a:buNone/>
-              <a:defRPr>
-                <a:solidFill>
-                  <a:schemeClr val="tx1">
-                    <a:tint val="75000"/>
-                  </a:schemeClr>
-                </a:solidFill>
-              </a:defRPr>
+              <a:defRPr sz="2000"/>
             </a:lvl2pPr>
             <a:lvl3pPr marL="914400" indent="0" algn="ctr">
               <a:buNone/>
-              <a:defRPr>
-                <a:solidFill>
-                  <a:schemeClr val="tx1">
-                    <a:tint val="75000"/>
-                  </a:schemeClr>
-                </a:solidFill>
-              </a:defRPr>
+              <a:defRPr sz="1800"/>
             </a:lvl3pPr>
             <a:lvl4pPr marL="1371600" indent="0" algn="ctr">
               <a:buNone/>
-              <a:defRPr>
-                <a:solidFill>
-                  <a:schemeClr val="tx1">
-                    <a:tint val="75000"/>
-                  </a:schemeClr>
-                </a:solidFill>
-              </a:defRPr>
+              <a:defRPr sz="1600"/>
             </a:lvl4pPr>
             <a:lvl5pPr marL="1828800" indent="0" algn="ctr">
               <a:buNone/>
-              <a:defRPr>
-                <a:solidFill>
-                  <a:schemeClr val="tx1">
-                    <a:tint val="75000"/>
-                  </a:schemeClr>
-                </a:solidFill>
-              </a:defRPr>
+              <a:defRPr sz="1600"/>
             </a:lvl5pPr>
             <a:lvl6pPr marL="2286000" indent="0" algn="ctr">
               <a:buNone/>
-              <a:defRPr>
-                <a:solidFill>
-                  <a:schemeClr val="tx1">
-                    <a:tint val="75000"/>
-                  </a:schemeClr>
-                </a:solidFill>
-              </a:defRPr>
+              <a:defRPr sz="1600"/>
             </a:lvl6pPr>
             <a:lvl7pPr marL="2743200" indent="0" algn="ctr">
               <a:buNone/>
-              <a:defRPr>
-                <a:solidFill>
-                  <a:schemeClr val="tx1">
-                    <a:tint val="75000"/>
-                  </a:schemeClr>
-                </a:solidFill>
-              </a:defRPr>
+              <a:defRPr sz="1600"/>
             </a:lvl7pPr>
             <a:lvl8pPr marL="3200400" indent="0" algn="ctr">
               <a:buNone/>
-              <a:defRPr>
-                <a:solidFill>
-                  <a:schemeClr val="tx1">
-                    <a:tint val="75000"/>
-                  </a:schemeClr>
-                </a:solidFill>
-              </a:defRPr>
+              <a:defRPr sz="1600"/>
             </a:lvl8pPr>
             <a:lvl9pPr marL="3657600" indent="0" algn="ctr">
               <a:buNone/>
-              <a:defRPr>
-                <a:solidFill>
-                  <a:schemeClr val="tx1">
-                    <a:tint val="75000"/>
-                  </a:schemeClr>
-                </a:solidFill>
-              </a:defRPr>
+              <a:defRPr sz="1600"/>
             </a:lvl9pPr>
           </a:lstStyle>
           <a:p>
             <a:r>
-              <a:rPr lang="en-US" smtClean="0"/>
-              <a:t>Click to edit Master subtitle style</a:t>
-            </a:r>
-            <a:endParaRPr lang="en-US"/>
-          </a:p>
-        </p:txBody>
-      </p:sp>
-      <p:sp>
-        <p:nvSpPr>
-          <p:cNvPr id="4" name="Date Placeholder 3"/>
+              <a:rPr lang="pt-BR"/>
+              <a:t>Clique para editar o estilo do subtítulo Mestre</a:t>
+            </a:r>
+          </a:p>
+        </p:txBody>
+      </p:sp>
+      <p:sp>
+        <p:nvSpPr>
+          <p:cNvPr id="4" name="Espaço Reservado para Data 3">
+            <a:extLst>
+              <a:ext uri="{FF2B5EF4-FFF2-40B4-BE49-F238E27FC236}">
+                <a16:creationId xmlns:a16="http://schemas.microsoft.com/office/drawing/2014/main" id="{A9AD0D8A-B38E-2281-5FF1-CB0E444A1603}"/>
+              </a:ext>
+            </a:extLst>
+          </p:cNvPr>
           <p:cNvSpPr>
             <a:spLocks noGrp="1"/>
           </p:cNvSpPr>
@@ -288,17 +254,23 @@
           <a:bodyPr/>
           <a:lstStyle/>
           <a:p>
-            <a:fld id="{5BCAD085-E8A6-8845-BD4E-CB4CCA059FC4}" type="datetimeFigureOut">
-              <a:rPr lang="en-US" smtClean="0"/>
-              <a:t>1/27/13</a:t>
+            <a:fld id="{22C9067A-926A-4F91-B7AE-7AC6F651DD3F}" type="datetimeFigureOut">
+              <a:rPr lang="pt-BR" smtClean="0"/>
+              <a:t>06/07/2026</a:t>
             </a:fld>
-            <a:endParaRPr lang="en-US"/>
-          </a:p>
-        </p:txBody>
-      </p:sp>
-      <p:sp>
-        <p:nvSpPr>
-          <p:cNvPr id="5" name="Footer Placeholder 4"/>
+            <a:endParaRPr lang="pt-BR"/>
+          </a:p>
+        </p:txBody>
+      </p:sp>
+      <p:sp>
+        <p:nvSpPr>
+          <p:cNvPr id="5" name="Espaço Reservado para Rodapé 4">
+            <a:extLst>
+              <a:ext uri="{FF2B5EF4-FFF2-40B4-BE49-F238E27FC236}">
+                <a16:creationId xmlns:a16="http://schemas.microsoft.com/office/drawing/2014/main" id="{8FFBC167-56FC-C95D-D930-CF30B92BCCA7}"/>
+              </a:ext>
+            </a:extLst>
+          </p:cNvPr>
           <p:cNvSpPr>
             <a:spLocks noGrp="1"/>
           </p:cNvSpPr>
@@ -311,13 +283,19 @@
           <a:bodyPr/>
           <a:lstStyle/>
           <a:p>
-            <a:endParaRPr lang="en-US"/>
-          </a:p>
-        </p:txBody>
-      </p:sp>
-      <p:sp>
-        <p:nvSpPr>
-          <p:cNvPr id="6" name="Slide Number Placeholder 5"/>
+            <a:endParaRPr lang="pt-BR"/>
+          </a:p>
+        </p:txBody>
+      </p:sp>
+      <p:sp>
+        <p:nvSpPr>
+          <p:cNvPr id="6" name="Espaço Reservado para Número de Slide 5">
+            <a:extLst>
+              <a:ext uri="{FF2B5EF4-FFF2-40B4-BE49-F238E27FC236}">
+                <a16:creationId xmlns:a16="http://schemas.microsoft.com/office/drawing/2014/main" id="{C93E696C-CCDA-5483-1948-145A04BE5647}"/>
+              </a:ext>
+            </a:extLst>
+          </p:cNvPr>
           <p:cNvSpPr>
             <a:spLocks noGrp="1"/>
           </p:cNvSpPr>
@@ -330,18 +308,18 @@
           <a:bodyPr/>
           <a:lstStyle/>
           <a:p>
-            <a:fld id="{C1FF6DA9-008F-8B48-92A6-B652298478BF}" type="slidenum">
-              <a:rPr lang="en-US" smtClean="0"/>
-              <a:t>‹#›</a:t>
+            <a:fld id="{04F480B6-C421-4DC2-BA7E-81BCB3D20179}" type="slidenum">
+              <a:rPr lang="pt-BR" smtClean="0"/>
+              <a:t>‹nº›</a:t>
             </a:fld>
-            <a:endParaRPr lang="en-US"/>
+            <a:endParaRPr lang="pt-BR"/>
           </a:p>
         </p:txBody>
       </p:sp>
     </p:spTree>
     <p:extLst>
       <p:ext uri="{BB962C8B-B14F-4D97-AF65-F5344CB8AC3E}">
-        <p14:creationId xmlns:p14="http://schemas.microsoft.com/office/powerpoint/2010/main" val="3168075583"/>
+        <p14:creationId xmlns:p14="http://schemas.microsoft.com/office/powerpoint/2010/main" val="1614711945"/>
       </p:ext>
     </p:extLst>
   </p:cSld>
@@ -353,7 +331,7 @@
 
 <file path=ppt/slideLayouts/slideLayout10.xml><?xml version="1.0" encoding="utf-8"?>
 <p:sldLayout xmlns:a="http://schemas.openxmlformats.org/drawingml/2006/main" xmlns:r="http://schemas.openxmlformats.org/officeDocument/2006/relationships" xmlns:p="http://schemas.openxmlformats.org/presentationml/2006/main" type="vertTx" preserve="1">
-  <p:cSld name="Title and Vertical Text">
+  <p:cSld name="Título e Texto Vertical">
     <p:spTree>
       <p:nvGrpSpPr>
         <p:cNvPr id="1" name=""/>
@@ -370,7 +348,13 @@
       </p:grpSpPr>
       <p:sp>
         <p:nvSpPr>
-          <p:cNvPr id="2" name="Title 1"/>
+          <p:cNvPr id="2" name="Título 1">
+            <a:extLst>
+              <a:ext uri="{FF2B5EF4-FFF2-40B4-BE49-F238E27FC236}">
+                <a16:creationId xmlns:a16="http://schemas.microsoft.com/office/drawing/2014/main" id="{0BA404BD-F8D4-FE7C-74ED-94E49EECB6EB}"/>
+              </a:ext>
+            </a:extLst>
+          </p:cNvPr>
           <p:cNvSpPr>
             <a:spLocks noGrp="1"/>
           </p:cNvSpPr>
@@ -384,16 +368,21 @@
           <a:lstStyle/>
           <a:p>
             <a:r>
-              <a:rPr lang="en-US" smtClean="0"/>
-              <a:t>Click to edit Master title style</a:t>
-            </a:r>
-            <a:endParaRPr lang="en-US"/>
-          </a:p>
-        </p:txBody>
-      </p:sp>
-      <p:sp>
-        <p:nvSpPr>
-          <p:cNvPr id="3" name="Vertical Text Placeholder 2"/>
+              <a:rPr lang="pt-BR"/>
+              <a:t>Clique para editar o título Mestre</a:t>
+            </a:r>
+          </a:p>
+        </p:txBody>
+      </p:sp>
+      <p:sp>
+        <p:nvSpPr>
+          <p:cNvPr id="3" name="Espaço Reservado para Texto Vertical 2">
+            <a:extLst>
+              <a:ext uri="{FF2B5EF4-FFF2-40B4-BE49-F238E27FC236}">
+                <a16:creationId xmlns:a16="http://schemas.microsoft.com/office/drawing/2014/main" id="{E6E7BD44-7189-3553-EF5A-331BCBF13B38}"/>
+              </a:ext>
+            </a:extLst>
+          </p:cNvPr>
           <p:cNvSpPr>
             <a:spLocks noGrp="1"/>
           </p:cNvSpPr>
@@ -408,44 +397,49 @@
           <a:p>
             <a:pPr lvl="0"/>
             <a:r>
-              <a:rPr lang="en-US" smtClean="0"/>
-              <a:t>Click to edit Master text styles</a:t>
+              <a:rPr lang="pt-BR"/>
+              <a:t>Clique para editar os estilos de texto Mestres</a:t>
             </a:r>
           </a:p>
           <a:p>
             <a:pPr lvl="1"/>
             <a:r>
-              <a:rPr lang="en-US" smtClean="0"/>
-              <a:t>Second level</a:t>
+              <a:rPr lang="pt-BR"/>
+              <a:t>Segundo nível</a:t>
             </a:r>
           </a:p>
           <a:p>
             <a:pPr lvl="2"/>
             <a:r>
-              <a:rPr lang="en-US" smtClean="0"/>
-              <a:t>Third level</a:t>
+              <a:rPr lang="pt-BR"/>
+              <a:t>Terceiro nível</a:t>
             </a:r>
           </a:p>
           <a:p>
             <a:pPr lvl="3"/>
             <a:r>
-              <a:rPr lang="en-US" smtClean="0"/>
-              <a:t>Fourth level</a:t>
+              <a:rPr lang="pt-BR"/>
+              <a:t>Quarto nível</a:t>
             </a:r>
           </a:p>
           <a:p>
             <a:pPr lvl="4"/>
             <a:r>
-              <a:rPr lang="en-US" smtClean="0"/>
-              <a:t>Fifth level</a:t>
-            </a:r>
-            <a:endParaRPr lang="en-US"/>
-          </a:p>
-        </p:txBody>
-      </p:sp>
-      <p:sp>
-        <p:nvSpPr>
-          <p:cNvPr id="4" name="Date Placeholder 3"/>
+              <a:rPr lang="pt-BR"/>
+              <a:t>Quinto nível</a:t>
+            </a:r>
+          </a:p>
+        </p:txBody>
+      </p:sp>
+      <p:sp>
+        <p:nvSpPr>
+          <p:cNvPr id="4" name="Espaço Reservado para Data 3">
+            <a:extLst>
+              <a:ext uri="{FF2B5EF4-FFF2-40B4-BE49-F238E27FC236}">
+                <a16:creationId xmlns:a16="http://schemas.microsoft.com/office/drawing/2014/main" id="{99793DA4-8D4D-4919-CDBF-E0E0A6694B5E}"/>
+              </a:ext>
+            </a:extLst>
+          </p:cNvPr>
           <p:cNvSpPr>
             <a:spLocks noGrp="1"/>
           </p:cNvSpPr>
@@ -458,17 +452,23 @@
           <a:bodyPr/>
           <a:lstStyle/>
           <a:p>
-            <a:fld id="{5BCAD085-E8A6-8845-BD4E-CB4CCA059FC4}" type="datetimeFigureOut">
-              <a:rPr lang="en-US" smtClean="0"/>
-              <a:t>1/27/13</a:t>
+            <a:fld id="{22C9067A-926A-4F91-B7AE-7AC6F651DD3F}" type="datetimeFigureOut">
+              <a:rPr lang="pt-BR" smtClean="0"/>
+              <a:t>06/07/2026</a:t>
             </a:fld>
-            <a:endParaRPr lang="en-US"/>
-          </a:p>
-        </p:txBody>
-      </p:sp>
-      <p:sp>
-        <p:nvSpPr>
-          <p:cNvPr id="5" name="Footer Placeholder 4"/>
+            <a:endParaRPr lang="pt-BR"/>
+          </a:p>
+        </p:txBody>
+      </p:sp>
+      <p:sp>
+        <p:nvSpPr>
+          <p:cNvPr id="5" name="Espaço Reservado para Rodapé 4">
+            <a:extLst>
+              <a:ext uri="{FF2B5EF4-FFF2-40B4-BE49-F238E27FC236}">
+                <a16:creationId xmlns:a16="http://schemas.microsoft.com/office/drawing/2014/main" id="{42388298-52ED-3551-0840-99EAED0D3CE5}"/>
+              </a:ext>
+            </a:extLst>
+          </p:cNvPr>
           <p:cNvSpPr>
             <a:spLocks noGrp="1"/>
           </p:cNvSpPr>
@@ -481,13 +481,19 @@
           <a:bodyPr/>
           <a:lstStyle/>
           <a:p>
-            <a:endParaRPr lang="en-US"/>
-          </a:p>
-        </p:txBody>
-      </p:sp>
-      <p:sp>
-        <p:nvSpPr>
-          <p:cNvPr id="6" name="Slide Number Placeholder 5"/>
+            <a:endParaRPr lang="pt-BR"/>
+          </a:p>
+        </p:txBody>
+      </p:sp>
+      <p:sp>
+        <p:nvSpPr>
+          <p:cNvPr id="6" name="Espaço Reservado para Número de Slide 5">
+            <a:extLst>
+              <a:ext uri="{FF2B5EF4-FFF2-40B4-BE49-F238E27FC236}">
+                <a16:creationId xmlns:a16="http://schemas.microsoft.com/office/drawing/2014/main" id="{9114A1E4-43F1-CF5C-C76E-472421A0191D}"/>
+              </a:ext>
+            </a:extLst>
+          </p:cNvPr>
           <p:cNvSpPr>
             <a:spLocks noGrp="1"/>
           </p:cNvSpPr>
@@ -500,18 +506,18 @@
           <a:bodyPr/>
           <a:lstStyle/>
           <a:p>
-            <a:fld id="{C1FF6DA9-008F-8B48-92A6-B652298478BF}" type="slidenum">
-              <a:rPr lang="en-US" smtClean="0"/>
-              <a:t>‹#›</a:t>
+            <a:fld id="{04F480B6-C421-4DC2-BA7E-81BCB3D20179}" type="slidenum">
+              <a:rPr lang="pt-BR" smtClean="0"/>
+              <a:t>‹nº›</a:t>
             </a:fld>
-            <a:endParaRPr lang="en-US"/>
+            <a:endParaRPr lang="pt-BR"/>
           </a:p>
         </p:txBody>
       </p:sp>
     </p:spTree>
     <p:extLst>
       <p:ext uri="{BB962C8B-B14F-4D97-AF65-F5344CB8AC3E}">
-        <p14:creationId xmlns:p14="http://schemas.microsoft.com/office/powerpoint/2010/main" val="2910927964"/>
+        <p14:creationId xmlns:p14="http://schemas.microsoft.com/office/powerpoint/2010/main" val="3387983571"/>
       </p:ext>
     </p:extLst>
   </p:cSld>
@@ -523,7 +529,7 @@
 
 <file path=ppt/slideLayouts/slideLayout11.xml><?xml version="1.0" encoding="utf-8"?>
 <p:sldLayout xmlns:a="http://schemas.openxmlformats.org/drawingml/2006/main" xmlns:r="http://schemas.openxmlformats.org/officeDocument/2006/relationships" xmlns:p="http://schemas.openxmlformats.org/presentationml/2006/main" type="vertTitleAndTx" preserve="1">
-  <p:cSld name="Vertical Title and Text">
+  <p:cSld name="Texto e Título Vertical">
     <p:spTree>
       <p:nvGrpSpPr>
         <p:cNvPr id="1" name=""/>
@@ -540,7 +546,13 @@
       </p:grpSpPr>
       <p:sp>
         <p:nvSpPr>
-          <p:cNvPr id="2" name="Vertical Title 1"/>
+          <p:cNvPr id="2" name="Título Vertical 1">
+            <a:extLst>
+              <a:ext uri="{FF2B5EF4-FFF2-40B4-BE49-F238E27FC236}">
+                <a16:creationId xmlns:a16="http://schemas.microsoft.com/office/drawing/2014/main" id="{E0A1C8C7-AF17-D372-B599-9A08884C1882}"/>
+              </a:ext>
+            </a:extLst>
+          </p:cNvPr>
           <p:cNvSpPr>
             <a:spLocks noGrp="1"/>
           </p:cNvSpPr>
@@ -550,8 +562,8 @@
         </p:nvSpPr>
         <p:spPr>
           <a:xfrm>
-            <a:off x="6629400" y="274638"/>
-            <a:ext cx="2057400" cy="5851525"/>
+            <a:off x="8724900" y="365125"/>
+            <a:ext cx="2628900" cy="5811838"/>
           </a:xfrm>
         </p:spPr>
         <p:txBody>
@@ -559,16 +571,21 @@
           <a:lstStyle/>
           <a:p>
             <a:r>
-              <a:rPr lang="en-US" smtClean="0"/>
-              <a:t>Click to edit Master title style</a:t>
-            </a:r>
-            <a:endParaRPr lang="en-US"/>
-          </a:p>
-        </p:txBody>
-      </p:sp>
-      <p:sp>
-        <p:nvSpPr>
-          <p:cNvPr id="3" name="Vertical Text Placeholder 2"/>
+              <a:rPr lang="pt-BR"/>
+              <a:t>Clique para editar o título Mestre</a:t>
+            </a:r>
+          </a:p>
+        </p:txBody>
+      </p:sp>
+      <p:sp>
+        <p:nvSpPr>
+          <p:cNvPr id="3" name="Espaço Reservado para Texto Vertical 2">
+            <a:extLst>
+              <a:ext uri="{FF2B5EF4-FFF2-40B4-BE49-F238E27FC236}">
+                <a16:creationId xmlns:a16="http://schemas.microsoft.com/office/drawing/2014/main" id="{6B958C66-8FFB-CC86-13A3-F1AC2FF191FE}"/>
+              </a:ext>
+            </a:extLst>
+          </p:cNvPr>
           <p:cNvSpPr>
             <a:spLocks noGrp="1"/>
           </p:cNvSpPr>
@@ -578,8 +595,8 @@
         </p:nvSpPr>
         <p:spPr>
           <a:xfrm>
-            <a:off x="457200" y="274638"/>
-            <a:ext cx="6019800" cy="5851525"/>
+            <a:off x="838200" y="365125"/>
+            <a:ext cx="7734300" cy="5811838"/>
           </a:xfrm>
         </p:spPr>
         <p:txBody>
@@ -588,44 +605,49 @@
           <a:p>
             <a:pPr lvl="0"/>
             <a:r>
-              <a:rPr lang="en-US" smtClean="0"/>
-              <a:t>Click to edit Master text styles</a:t>
+              <a:rPr lang="pt-BR"/>
+              <a:t>Clique para editar os estilos de texto Mestres</a:t>
             </a:r>
           </a:p>
           <a:p>
             <a:pPr lvl="1"/>
             <a:r>
-              <a:rPr lang="en-US" smtClean="0"/>
-              <a:t>Second level</a:t>
+              <a:rPr lang="pt-BR"/>
+              <a:t>Segundo nível</a:t>
             </a:r>
           </a:p>
           <a:p>
             <a:pPr lvl="2"/>
             <a:r>
-              <a:rPr lang="en-US" smtClean="0"/>
-              <a:t>Third level</a:t>
+              <a:rPr lang="pt-BR"/>
+              <a:t>Terceiro nível</a:t>
             </a:r>
           </a:p>
           <a:p>
             <a:pPr lvl="3"/>
             <a:r>
-              <a:rPr lang="en-US" smtClean="0"/>
-              <a:t>Fourth level</a:t>
+              <a:rPr lang="pt-BR"/>
+              <a:t>Quarto nível</a:t>
             </a:r>
           </a:p>
           <a:p>
             <a:pPr lvl="4"/>
             <a:r>
-              <a:rPr lang="en-US" smtClean="0"/>
-              <a:t>Fifth level</a:t>
-            </a:r>
-            <a:endParaRPr lang="en-US"/>
-          </a:p>
-        </p:txBody>
-      </p:sp>
-      <p:sp>
-        <p:nvSpPr>
-          <p:cNvPr id="4" name="Date Placeholder 3"/>
+              <a:rPr lang="pt-BR"/>
+              <a:t>Quinto nível</a:t>
+            </a:r>
+          </a:p>
+        </p:txBody>
+      </p:sp>
+      <p:sp>
+        <p:nvSpPr>
+          <p:cNvPr id="4" name="Espaço Reservado para Data 3">
+            <a:extLst>
+              <a:ext uri="{FF2B5EF4-FFF2-40B4-BE49-F238E27FC236}">
+                <a16:creationId xmlns:a16="http://schemas.microsoft.com/office/drawing/2014/main" id="{B6281462-BFD2-CF2E-D9CD-E4F191A25A51}"/>
+              </a:ext>
+            </a:extLst>
+          </p:cNvPr>
           <p:cNvSpPr>
             <a:spLocks noGrp="1"/>
           </p:cNvSpPr>
@@ -638,17 +660,23 @@
           <a:bodyPr/>
           <a:lstStyle/>
           <a:p>
-            <a:fld id="{5BCAD085-E8A6-8845-BD4E-CB4CCA059FC4}" type="datetimeFigureOut">
-              <a:rPr lang="en-US" smtClean="0"/>
-              <a:t>1/27/13</a:t>
+            <a:fld id="{22C9067A-926A-4F91-B7AE-7AC6F651DD3F}" type="datetimeFigureOut">
+              <a:rPr lang="pt-BR" smtClean="0"/>
+              <a:t>06/07/2026</a:t>
             </a:fld>
-            <a:endParaRPr lang="en-US"/>
-          </a:p>
-        </p:txBody>
-      </p:sp>
-      <p:sp>
-        <p:nvSpPr>
-          <p:cNvPr id="5" name="Footer Placeholder 4"/>
+            <a:endParaRPr lang="pt-BR"/>
+          </a:p>
+        </p:txBody>
+      </p:sp>
+      <p:sp>
+        <p:nvSpPr>
+          <p:cNvPr id="5" name="Espaço Reservado para Rodapé 4">
+            <a:extLst>
+              <a:ext uri="{FF2B5EF4-FFF2-40B4-BE49-F238E27FC236}">
+                <a16:creationId xmlns:a16="http://schemas.microsoft.com/office/drawing/2014/main" id="{DBAD66EE-0306-4169-C3A7-5C3912F63571}"/>
+              </a:ext>
+            </a:extLst>
+          </p:cNvPr>
           <p:cNvSpPr>
             <a:spLocks noGrp="1"/>
           </p:cNvSpPr>
@@ -661,13 +689,19 @@
           <a:bodyPr/>
           <a:lstStyle/>
           <a:p>
-            <a:endParaRPr lang="en-US"/>
-          </a:p>
-        </p:txBody>
-      </p:sp>
-      <p:sp>
-        <p:nvSpPr>
-          <p:cNvPr id="6" name="Slide Number Placeholder 5"/>
+            <a:endParaRPr lang="pt-BR"/>
+          </a:p>
+        </p:txBody>
+      </p:sp>
+      <p:sp>
+        <p:nvSpPr>
+          <p:cNvPr id="6" name="Espaço Reservado para Número de Slide 5">
+            <a:extLst>
+              <a:ext uri="{FF2B5EF4-FFF2-40B4-BE49-F238E27FC236}">
+                <a16:creationId xmlns:a16="http://schemas.microsoft.com/office/drawing/2014/main" id="{FF66CAF3-9636-0764-B837-87ADE710EFE3}"/>
+              </a:ext>
+            </a:extLst>
+          </p:cNvPr>
           <p:cNvSpPr>
             <a:spLocks noGrp="1"/>
           </p:cNvSpPr>
@@ -680,18 +714,18 @@
           <a:bodyPr/>
           <a:lstStyle/>
           <a:p>
-            <a:fld id="{C1FF6DA9-008F-8B48-92A6-B652298478BF}" type="slidenum">
-              <a:rPr lang="en-US" smtClean="0"/>
-              <a:t>‹#›</a:t>
+            <a:fld id="{04F480B6-C421-4DC2-BA7E-81BCB3D20179}" type="slidenum">
+              <a:rPr lang="pt-BR" smtClean="0"/>
+              <a:t>‹nº›</a:t>
             </a:fld>
-            <a:endParaRPr lang="en-US"/>
+            <a:endParaRPr lang="pt-BR"/>
           </a:p>
         </p:txBody>
       </p:sp>
     </p:spTree>
     <p:extLst>
       <p:ext uri="{BB962C8B-B14F-4D97-AF65-F5344CB8AC3E}">
-        <p14:creationId xmlns:p14="http://schemas.microsoft.com/office/powerpoint/2010/main" val="3612223792"/>
+        <p14:creationId xmlns:p14="http://schemas.microsoft.com/office/powerpoint/2010/main" val="4147558353"/>
       </p:ext>
     </p:extLst>
   </p:cSld>
@@ -703,7 +737,7 @@
 
 <file path=ppt/slideLayouts/slideLayout2.xml><?xml version="1.0" encoding="utf-8"?>
 <p:sldLayout xmlns:a="http://schemas.openxmlformats.org/drawingml/2006/main" xmlns:r="http://schemas.openxmlformats.org/officeDocument/2006/relationships" xmlns:p="http://schemas.openxmlformats.org/presentationml/2006/main" type="obj" preserve="1">
-  <p:cSld name="Title and Content">
+  <p:cSld name="Título e Conteúdo">
     <p:spTree>
       <p:nvGrpSpPr>
         <p:cNvPr id="1" name=""/>
@@ -720,7 +754,13 @@
       </p:grpSpPr>
       <p:sp>
         <p:nvSpPr>
-          <p:cNvPr id="2" name="Title 1"/>
+          <p:cNvPr id="2" name="Título 1">
+            <a:extLst>
+              <a:ext uri="{FF2B5EF4-FFF2-40B4-BE49-F238E27FC236}">
+                <a16:creationId xmlns:a16="http://schemas.microsoft.com/office/drawing/2014/main" id="{0FA9A3EC-1DAB-B523-4D8E-21E7874C31B5}"/>
+              </a:ext>
+            </a:extLst>
+          </p:cNvPr>
           <p:cNvSpPr>
             <a:spLocks noGrp="1"/>
           </p:cNvSpPr>
@@ -734,16 +774,21 @@
           <a:lstStyle/>
           <a:p>
             <a:r>
-              <a:rPr lang="en-US" smtClean="0"/>
-              <a:t>Click to edit Master title style</a:t>
-            </a:r>
-            <a:endParaRPr lang="en-US"/>
-          </a:p>
-        </p:txBody>
-      </p:sp>
-      <p:sp>
-        <p:nvSpPr>
-          <p:cNvPr id="3" name="Content Placeholder 2"/>
+              <a:rPr lang="pt-BR"/>
+              <a:t>Clique para editar o título Mestre</a:t>
+            </a:r>
+          </a:p>
+        </p:txBody>
+      </p:sp>
+      <p:sp>
+        <p:nvSpPr>
+          <p:cNvPr id="3" name="Espaço Reservado para Conteúdo 2">
+            <a:extLst>
+              <a:ext uri="{FF2B5EF4-FFF2-40B4-BE49-F238E27FC236}">
+                <a16:creationId xmlns:a16="http://schemas.microsoft.com/office/drawing/2014/main" id="{9678A56E-D4D3-3B8F-AA3D-F7CBE1EB1069}"/>
+              </a:ext>
+            </a:extLst>
+          </p:cNvPr>
           <p:cNvSpPr>
             <a:spLocks noGrp="1"/>
           </p:cNvSpPr>
@@ -758,44 +803,49 @@
           <a:p>
             <a:pPr lvl="0"/>
             <a:r>
-              <a:rPr lang="en-US" smtClean="0"/>
-              <a:t>Click to edit Master text styles</a:t>
+              <a:rPr lang="pt-BR"/>
+              <a:t>Clique para editar os estilos de texto Mestres</a:t>
             </a:r>
           </a:p>
           <a:p>
             <a:pPr lvl="1"/>
             <a:r>
-              <a:rPr lang="en-US" smtClean="0"/>
-              <a:t>Second level</a:t>
+              <a:rPr lang="pt-BR"/>
+              <a:t>Segundo nível</a:t>
             </a:r>
           </a:p>
           <a:p>
             <a:pPr lvl="2"/>
             <a:r>
-              <a:rPr lang="en-US" smtClean="0"/>
-              <a:t>Third level</a:t>
+              <a:rPr lang="pt-BR"/>
+              <a:t>Terceiro nível</a:t>
             </a:r>
           </a:p>
           <a:p>
             <a:pPr lvl="3"/>
             <a:r>
-              <a:rPr lang="en-US" smtClean="0"/>
-              <a:t>Fourth level</a:t>
+              <a:rPr lang="pt-BR"/>
+              <a:t>Quarto nível</a:t>
             </a:r>
           </a:p>
           <a:p>
             <a:pPr lvl="4"/>
             <a:r>
-              <a:rPr lang="en-US" smtClean="0"/>
-              <a:t>Fifth level</a:t>
-            </a:r>
-            <a:endParaRPr lang="en-US"/>
-          </a:p>
-        </p:txBody>
-      </p:sp>
-      <p:sp>
-        <p:nvSpPr>
-          <p:cNvPr id="4" name="Date Placeholder 3"/>
+              <a:rPr lang="pt-BR"/>
+              <a:t>Quinto nível</a:t>
+            </a:r>
+          </a:p>
+        </p:txBody>
+      </p:sp>
+      <p:sp>
+        <p:nvSpPr>
+          <p:cNvPr id="4" name="Espaço Reservado para Data 3">
+            <a:extLst>
+              <a:ext uri="{FF2B5EF4-FFF2-40B4-BE49-F238E27FC236}">
+                <a16:creationId xmlns:a16="http://schemas.microsoft.com/office/drawing/2014/main" id="{B63D57AC-FED1-019F-0684-61BE16C7CE42}"/>
+              </a:ext>
+            </a:extLst>
+          </p:cNvPr>
           <p:cNvSpPr>
             <a:spLocks noGrp="1"/>
           </p:cNvSpPr>
@@ -808,17 +858,23 @@
           <a:bodyPr/>
           <a:lstStyle/>
           <a:p>
-            <a:fld id="{5BCAD085-E8A6-8845-BD4E-CB4CCA059FC4}" type="datetimeFigureOut">
-              <a:rPr lang="en-US" smtClean="0"/>
-              <a:t>1/27/13</a:t>
+            <a:fld id="{22C9067A-926A-4F91-B7AE-7AC6F651DD3F}" type="datetimeFigureOut">
+              <a:rPr lang="pt-BR" smtClean="0"/>
+              <a:t>06/07/2026</a:t>
             </a:fld>
-            <a:endParaRPr lang="en-US"/>
-          </a:p>
-        </p:txBody>
-      </p:sp>
-      <p:sp>
-        <p:nvSpPr>
-          <p:cNvPr id="5" name="Footer Placeholder 4"/>
+            <a:endParaRPr lang="pt-BR"/>
+          </a:p>
+        </p:txBody>
+      </p:sp>
+      <p:sp>
+        <p:nvSpPr>
+          <p:cNvPr id="5" name="Espaço Reservado para Rodapé 4">
+            <a:extLst>
+              <a:ext uri="{FF2B5EF4-FFF2-40B4-BE49-F238E27FC236}">
+                <a16:creationId xmlns:a16="http://schemas.microsoft.com/office/drawing/2014/main" id="{254946E7-6518-E3DE-FE5A-75C33A6CA8CD}"/>
+              </a:ext>
+            </a:extLst>
+          </p:cNvPr>
           <p:cNvSpPr>
             <a:spLocks noGrp="1"/>
           </p:cNvSpPr>
@@ -831,13 +887,19 @@
           <a:bodyPr/>
           <a:lstStyle/>
           <a:p>
-            <a:endParaRPr lang="en-US"/>
-          </a:p>
-        </p:txBody>
-      </p:sp>
-      <p:sp>
-        <p:nvSpPr>
-          <p:cNvPr id="6" name="Slide Number Placeholder 5"/>
+            <a:endParaRPr lang="pt-BR"/>
+          </a:p>
+        </p:txBody>
+      </p:sp>
+      <p:sp>
+        <p:nvSpPr>
+          <p:cNvPr id="6" name="Espaço Reservado para Número de Slide 5">
+            <a:extLst>
+              <a:ext uri="{FF2B5EF4-FFF2-40B4-BE49-F238E27FC236}">
+                <a16:creationId xmlns:a16="http://schemas.microsoft.com/office/drawing/2014/main" id="{0F4913F4-F029-0845-CD23-6DE6510A1CE4}"/>
+              </a:ext>
+            </a:extLst>
+          </p:cNvPr>
           <p:cNvSpPr>
             <a:spLocks noGrp="1"/>
           </p:cNvSpPr>
@@ -850,18 +912,18 @@
           <a:bodyPr/>
           <a:lstStyle/>
           <a:p>
-            <a:fld id="{C1FF6DA9-008F-8B48-92A6-B652298478BF}" type="slidenum">
-              <a:rPr lang="en-US" smtClean="0"/>
-              <a:t>‹#›</a:t>
+            <a:fld id="{04F480B6-C421-4DC2-BA7E-81BCB3D20179}" type="slidenum">
+              <a:rPr lang="pt-BR" smtClean="0"/>
+              <a:t>‹nº›</a:t>
             </a:fld>
-            <a:endParaRPr lang="en-US"/>
+            <a:endParaRPr lang="pt-BR"/>
           </a:p>
         </p:txBody>
       </p:sp>
     </p:spTree>
     <p:extLst>
       <p:ext uri="{BB962C8B-B14F-4D97-AF65-F5344CB8AC3E}">
-        <p14:creationId xmlns:p14="http://schemas.microsoft.com/office/powerpoint/2010/main" val="2614314258"/>
+        <p14:creationId xmlns:p14="http://schemas.microsoft.com/office/powerpoint/2010/main" val="3928803863"/>
       </p:ext>
     </p:extLst>
   </p:cSld>
@@ -873,7 +935,7 @@
 
 <file path=ppt/slideLayouts/slideLayout3.xml><?xml version="1.0" encoding="utf-8"?>
 <p:sldLayout xmlns:a="http://schemas.openxmlformats.org/drawingml/2006/main" xmlns:r="http://schemas.openxmlformats.org/officeDocument/2006/relationships" xmlns:p="http://schemas.openxmlformats.org/presentationml/2006/main" type="secHead" preserve="1">
-  <p:cSld name="Section Header">
+  <p:cSld name="Cabeçalho da Seção">
     <p:spTree>
       <p:nvGrpSpPr>
         <p:cNvPr id="1" name=""/>
@@ -890,7 +952,13 @@
       </p:grpSpPr>
       <p:sp>
         <p:nvSpPr>
-          <p:cNvPr id="2" name="Title 1"/>
+          <p:cNvPr id="2" name="Título 1">
+            <a:extLst>
+              <a:ext uri="{FF2B5EF4-FFF2-40B4-BE49-F238E27FC236}">
+                <a16:creationId xmlns:a16="http://schemas.microsoft.com/office/drawing/2014/main" id="{66D1CB45-3874-9328-D9A3-25A23DB1ED87}"/>
+              </a:ext>
+            </a:extLst>
+          </p:cNvPr>
           <p:cNvSpPr>
             <a:spLocks noGrp="1"/>
           </p:cNvSpPr>
@@ -900,29 +968,34 @@
         </p:nvSpPr>
         <p:spPr>
           <a:xfrm>
-            <a:off x="722313" y="4406900"/>
-            <a:ext cx="7772400" cy="1362075"/>
+            <a:off x="831850" y="1709738"/>
+            <a:ext cx="10515600" cy="2852737"/>
           </a:xfrm>
         </p:spPr>
         <p:txBody>
-          <a:bodyPr anchor="t"/>
+          <a:bodyPr anchor="b"/>
           <a:lstStyle>
-            <a:lvl1pPr algn="l">
-              <a:defRPr sz="4000" b="1" cap="all"/>
+            <a:lvl1pPr>
+              <a:defRPr sz="6000"/>
             </a:lvl1pPr>
           </a:lstStyle>
           <a:p>
             <a:r>
-              <a:rPr lang="en-US" smtClean="0"/>
-              <a:t>Click to edit Master title style</a:t>
-            </a:r>
-            <a:endParaRPr lang="en-US"/>
-          </a:p>
-        </p:txBody>
-      </p:sp>
-      <p:sp>
-        <p:nvSpPr>
-          <p:cNvPr id="3" name="Text Placeholder 2"/>
+              <a:rPr lang="pt-BR"/>
+              <a:t>Clique para editar o título Mestre</a:t>
+            </a:r>
+          </a:p>
+        </p:txBody>
+      </p:sp>
+      <p:sp>
+        <p:nvSpPr>
+          <p:cNvPr id="3" name="Espaço Reservado para Texto 2">
+            <a:extLst>
+              <a:ext uri="{FF2B5EF4-FFF2-40B4-BE49-F238E27FC236}">
+                <a16:creationId xmlns:a16="http://schemas.microsoft.com/office/drawing/2014/main" id="{9ACA0548-671F-2730-6690-67E1882BC527}"/>
+              </a:ext>
+            </a:extLst>
+          </p:cNvPr>
           <p:cNvSpPr>
             <a:spLocks noGrp="1"/>
           </p:cNvSpPr>
@@ -932,99 +1005,99 @@
         </p:nvSpPr>
         <p:spPr>
           <a:xfrm>
-            <a:off x="722313" y="2906713"/>
-            <a:ext cx="7772400" cy="1500187"/>
+            <a:off x="831850" y="4589463"/>
+            <a:ext cx="10515600" cy="1500187"/>
           </a:xfrm>
         </p:spPr>
         <p:txBody>
-          <a:bodyPr anchor="b"/>
+          <a:bodyPr/>
           <a:lstStyle>
             <a:lvl1pPr marL="0" indent="0">
               <a:buNone/>
-              <a:defRPr sz="2000">
+              <a:defRPr sz="2400">
                 <a:solidFill>
                   <a:schemeClr val="tx1">
-                    <a:tint val="75000"/>
+                    <a:tint val="82000"/>
                   </a:schemeClr>
                 </a:solidFill>
               </a:defRPr>
             </a:lvl1pPr>
             <a:lvl2pPr marL="457200" indent="0">
               <a:buNone/>
-              <a:defRPr sz="1800">
+              <a:defRPr sz="2000">
                 <a:solidFill>
                   <a:schemeClr val="tx1">
-                    <a:tint val="75000"/>
+                    <a:tint val="82000"/>
                   </a:schemeClr>
                 </a:solidFill>
               </a:defRPr>
             </a:lvl2pPr>
             <a:lvl3pPr marL="914400" indent="0">
               <a:buNone/>
-              <a:defRPr sz="1600">
+              <a:defRPr sz="1800">
                 <a:solidFill>
                   <a:schemeClr val="tx1">
-                    <a:tint val="75000"/>
+                    <a:tint val="82000"/>
                   </a:schemeClr>
                 </a:solidFill>
               </a:defRPr>
             </a:lvl3pPr>
             <a:lvl4pPr marL="1371600" indent="0">
               <a:buNone/>
-              <a:defRPr sz="1400">
+              <a:defRPr sz="1600">
                 <a:solidFill>
                   <a:schemeClr val="tx1">
-                    <a:tint val="75000"/>
+                    <a:tint val="82000"/>
                   </a:schemeClr>
                 </a:solidFill>
               </a:defRPr>
             </a:lvl4pPr>
             <a:lvl5pPr marL="1828800" indent="0">
               <a:buNone/>
-              <a:defRPr sz="1400">
+              <a:defRPr sz="1600">
                 <a:solidFill>
                   <a:schemeClr val="tx1">
-                    <a:tint val="75000"/>
+                    <a:tint val="82000"/>
                   </a:schemeClr>
                 </a:solidFill>
               </a:defRPr>
             </a:lvl5pPr>
             <a:lvl6pPr marL="2286000" indent="0">
               <a:buNone/>
-              <a:defRPr sz="1400">
+              <a:defRPr sz="1600">
                 <a:solidFill>
                   <a:schemeClr val="tx1">
-                    <a:tint val="75000"/>
+                    <a:tint val="82000"/>
                   </a:schemeClr>
                 </a:solidFill>
               </a:defRPr>
             </a:lvl6pPr>
             <a:lvl7pPr marL="2743200" indent="0">
               <a:buNone/>
-              <a:defRPr sz="1400">
+              <a:defRPr sz="1600">
                 <a:solidFill>
                   <a:schemeClr val="tx1">
-                    <a:tint val="75000"/>
+                    <a:tint val="82000"/>
                   </a:schemeClr>
                 </a:solidFill>
               </a:defRPr>
             </a:lvl7pPr>
             <a:lvl8pPr marL="3200400" indent="0">
               <a:buNone/>
-              <a:defRPr sz="1400">
+              <a:defRPr sz="1600">
                 <a:solidFill>
                   <a:schemeClr val="tx1">
-                    <a:tint val="75000"/>
+                    <a:tint val="82000"/>
                   </a:schemeClr>
                 </a:solidFill>
               </a:defRPr>
             </a:lvl8pPr>
             <a:lvl9pPr marL="3657600" indent="0">
               <a:buNone/>
-              <a:defRPr sz="1400">
+              <a:defRPr sz="1600">
                 <a:solidFill>
                   <a:schemeClr val="tx1">
-                    <a:tint val="75000"/>
+                    <a:tint val="82000"/>
                   </a:schemeClr>
                 </a:solidFill>
               </a:defRPr>
@@ -1033,15 +1106,21 @@
           <a:p>
             <a:pPr lvl="0"/>
             <a:r>
-              <a:rPr lang="en-US" smtClean="0"/>
-              <a:t>Click to edit Master text styles</a:t>
-            </a:r>
-          </a:p>
-        </p:txBody>
-      </p:sp>
-      <p:sp>
-        <p:nvSpPr>
-          <p:cNvPr id="4" name="Date Placeholder 3"/>
+              <a:rPr lang="pt-BR"/>
+              <a:t>Clique para editar os estilos de texto Mestres</a:t>
+            </a:r>
+          </a:p>
+        </p:txBody>
+      </p:sp>
+      <p:sp>
+        <p:nvSpPr>
+          <p:cNvPr id="4" name="Espaço Reservado para Data 3">
+            <a:extLst>
+              <a:ext uri="{FF2B5EF4-FFF2-40B4-BE49-F238E27FC236}">
+                <a16:creationId xmlns:a16="http://schemas.microsoft.com/office/drawing/2014/main" id="{E272030D-CF83-648B-1070-0C7F673158CC}"/>
+              </a:ext>
+            </a:extLst>
+          </p:cNvPr>
           <p:cNvSpPr>
             <a:spLocks noGrp="1"/>
           </p:cNvSpPr>
@@ -1054,17 +1133,23 @@
           <a:bodyPr/>
           <a:lstStyle/>
           <a:p>
-            <a:fld id="{5BCAD085-E8A6-8845-BD4E-CB4CCA059FC4}" type="datetimeFigureOut">
-              <a:rPr lang="en-US" smtClean="0"/>
-              <a:t>1/27/13</a:t>
+            <a:fld id="{22C9067A-926A-4F91-B7AE-7AC6F651DD3F}" type="datetimeFigureOut">
+              <a:rPr lang="pt-BR" smtClean="0"/>
+              <a:t>06/07/2026</a:t>
             </a:fld>
-            <a:endParaRPr lang="en-US"/>
-          </a:p>
-        </p:txBody>
-      </p:sp>
-      <p:sp>
-        <p:nvSpPr>
-          <p:cNvPr id="5" name="Footer Placeholder 4"/>
+            <a:endParaRPr lang="pt-BR"/>
+          </a:p>
+        </p:txBody>
+      </p:sp>
+      <p:sp>
+        <p:nvSpPr>
+          <p:cNvPr id="5" name="Espaço Reservado para Rodapé 4">
+            <a:extLst>
+              <a:ext uri="{FF2B5EF4-FFF2-40B4-BE49-F238E27FC236}">
+                <a16:creationId xmlns:a16="http://schemas.microsoft.com/office/drawing/2014/main" id="{00BD736C-7D95-3B66-C32D-C2D06BCFCFD9}"/>
+              </a:ext>
+            </a:extLst>
+          </p:cNvPr>
           <p:cNvSpPr>
             <a:spLocks noGrp="1"/>
           </p:cNvSpPr>
@@ -1077,13 +1162,19 @@
           <a:bodyPr/>
           <a:lstStyle/>
           <a:p>
-            <a:endParaRPr lang="en-US"/>
-          </a:p>
-        </p:txBody>
-      </p:sp>
-      <p:sp>
-        <p:nvSpPr>
-          <p:cNvPr id="6" name="Slide Number Placeholder 5"/>
+            <a:endParaRPr lang="pt-BR"/>
+          </a:p>
+        </p:txBody>
+      </p:sp>
+      <p:sp>
+        <p:nvSpPr>
+          <p:cNvPr id="6" name="Espaço Reservado para Número de Slide 5">
+            <a:extLst>
+              <a:ext uri="{FF2B5EF4-FFF2-40B4-BE49-F238E27FC236}">
+                <a16:creationId xmlns:a16="http://schemas.microsoft.com/office/drawing/2014/main" id="{C7EB0F1E-8ACD-BB78-8749-21AC525C6DE5}"/>
+              </a:ext>
+            </a:extLst>
+          </p:cNvPr>
           <p:cNvSpPr>
             <a:spLocks noGrp="1"/>
           </p:cNvSpPr>
@@ -1096,18 +1187,18 @@
           <a:bodyPr/>
           <a:lstStyle/>
           <a:p>
-            <a:fld id="{C1FF6DA9-008F-8B48-92A6-B652298478BF}" type="slidenum">
-              <a:rPr lang="en-US" smtClean="0"/>
-              <a:t>‹#›</a:t>
+            <a:fld id="{04F480B6-C421-4DC2-BA7E-81BCB3D20179}" type="slidenum">
+              <a:rPr lang="pt-BR" smtClean="0"/>
+              <a:t>‹nº›</a:t>
             </a:fld>
-            <a:endParaRPr lang="en-US"/>
+            <a:endParaRPr lang="pt-BR"/>
           </a:p>
         </p:txBody>
       </p:sp>
     </p:spTree>
     <p:extLst>
       <p:ext uri="{BB962C8B-B14F-4D97-AF65-F5344CB8AC3E}">
-        <p14:creationId xmlns:p14="http://schemas.microsoft.com/office/powerpoint/2010/main" val="960648375"/>
+        <p14:creationId xmlns:p14="http://schemas.microsoft.com/office/powerpoint/2010/main" val="2811387612"/>
       </p:ext>
     </p:extLst>
   </p:cSld>
@@ -1119,7 +1210,7 @@
 
 <file path=ppt/slideLayouts/slideLayout4.xml><?xml version="1.0" encoding="utf-8"?>
 <p:sldLayout xmlns:a="http://schemas.openxmlformats.org/drawingml/2006/main" xmlns:r="http://schemas.openxmlformats.org/officeDocument/2006/relationships" xmlns:p="http://schemas.openxmlformats.org/presentationml/2006/main" type="twoObj" preserve="1">
-  <p:cSld name="Two Content">
+  <p:cSld name="Duas Partes de Conteúdo">
     <p:spTree>
       <p:nvGrpSpPr>
         <p:cNvPr id="1" name=""/>
@@ -1136,7 +1227,13 @@
       </p:grpSpPr>
       <p:sp>
         <p:nvSpPr>
-          <p:cNvPr id="2" name="Title 1"/>
+          <p:cNvPr id="2" name="Título 1">
+            <a:extLst>
+              <a:ext uri="{FF2B5EF4-FFF2-40B4-BE49-F238E27FC236}">
+                <a16:creationId xmlns:a16="http://schemas.microsoft.com/office/drawing/2014/main" id="{58C7D237-1A4F-956E-2870-7AF336AFC8D9}"/>
+              </a:ext>
+            </a:extLst>
+          </p:cNvPr>
           <p:cNvSpPr>
             <a:spLocks noGrp="1"/>
           </p:cNvSpPr>
@@ -1150,16 +1247,21 @@
           <a:lstStyle/>
           <a:p>
             <a:r>
-              <a:rPr lang="en-US" smtClean="0"/>
-              <a:t>Click to edit Master title style</a:t>
-            </a:r>
-            <a:endParaRPr lang="en-US"/>
-          </a:p>
-        </p:txBody>
-      </p:sp>
-      <p:sp>
-        <p:nvSpPr>
-          <p:cNvPr id="3" name="Content Placeholder 2"/>
+              <a:rPr lang="pt-BR"/>
+              <a:t>Clique para editar o título Mestre</a:t>
+            </a:r>
+          </a:p>
+        </p:txBody>
+      </p:sp>
+      <p:sp>
+        <p:nvSpPr>
+          <p:cNvPr id="3" name="Espaço Reservado para Conteúdo 2">
+            <a:extLst>
+              <a:ext uri="{FF2B5EF4-FFF2-40B4-BE49-F238E27FC236}">
+                <a16:creationId xmlns:a16="http://schemas.microsoft.com/office/drawing/2014/main" id="{05BA5D2A-0229-B467-4BF0-0D3FF6F069C4}"/>
+              </a:ext>
+            </a:extLst>
+          </p:cNvPr>
           <p:cNvSpPr>
             <a:spLocks noGrp="1"/>
           </p:cNvSpPr>
@@ -1169,82 +1271,59 @@
         </p:nvSpPr>
         <p:spPr>
           <a:xfrm>
-            <a:off x="457200" y="1600200"/>
-            <a:ext cx="4038600" cy="4525963"/>
+            <a:off x="838200" y="1825625"/>
+            <a:ext cx="5181600" cy="4351338"/>
           </a:xfrm>
         </p:spPr>
         <p:txBody>
           <a:bodyPr/>
-          <a:lstStyle>
-            <a:lvl1pPr>
-              <a:defRPr sz="2800"/>
-            </a:lvl1pPr>
-            <a:lvl2pPr>
-              <a:defRPr sz="2400"/>
-            </a:lvl2pPr>
-            <a:lvl3pPr>
-              <a:defRPr sz="2000"/>
-            </a:lvl3pPr>
-            <a:lvl4pPr>
-              <a:defRPr sz="1800"/>
-            </a:lvl4pPr>
-            <a:lvl5pPr>
-              <a:defRPr sz="1800"/>
-            </a:lvl5pPr>
-            <a:lvl6pPr>
-              <a:defRPr sz="1800"/>
-            </a:lvl6pPr>
-            <a:lvl7pPr>
-              <a:defRPr sz="1800"/>
-            </a:lvl7pPr>
-            <a:lvl8pPr>
-              <a:defRPr sz="1800"/>
-            </a:lvl8pPr>
-            <a:lvl9pPr>
-              <a:defRPr sz="1800"/>
-            </a:lvl9pPr>
-          </a:lstStyle>
+          <a:lstStyle/>
           <a:p>
             <a:pPr lvl="0"/>
             <a:r>
-              <a:rPr lang="en-US" smtClean="0"/>
-              <a:t>Click to edit Master text styles</a:t>
+              <a:rPr lang="pt-BR"/>
+              <a:t>Clique para editar os estilos de texto Mestres</a:t>
             </a:r>
           </a:p>
           <a:p>
             <a:pPr lvl="1"/>
             <a:r>
-              <a:rPr lang="en-US" smtClean="0"/>
-              <a:t>Second level</a:t>
+              <a:rPr lang="pt-BR"/>
+              <a:t>Segundo nível</a:t>
             </a:r>
           </a:p>
           <a:p>
             <a:pPr lvl="2"/>
             <a:r>
-              <a:rPr lang="en-US" smtClean="0"/>
-              <a:t>Third level</a:t>
+              <a:rPr lang="pt-BR"/>
+              <a:t>Terceiro nível</a:t>
             </a:r>
           </a:p>
           <a:p>
             <a:pPr lvl="3"/>
             <a:r>
-              <a:rPr lang="en-US" smtClean="0"/>
-              <a:t>Fourth level</a:t>
+              <a:rPr lang="pt-BR"/>
+              <a:t>Quarto nível</a:t>
             </a:r>
           </a:p>
           <a:p>
             <a:pPr lvl="4"/>
             <a:r>
-              <a:rPr lang="en-US" smtClean="0"/>
-              <a:t>Fifth level</a:t>
-            </a:r>
-            <a:endParaRPr lang="en-US"/>
-          </a:p>
-        </p:txBody>
-      </p:sp>
-      <p:sp>
-        <p:nvSpPr>
-          <p:cNvPr id="4" name="Content Placeholder 3"/>
+              <a:rPr lang="pt-BR"/>
+              <a:t>Quinto nível</a:t>
+            </a:r>
+          </a:p>
+        </p:txBody>
+      </p:sp>
+      <p:sp>
+        <p:nvSpPr>
+          <p:cNvPr id="4" name="Espaço Reservado para Conteúdo 3">
+            <a:extLst>
+              <a:ext uri="{FF2B5EF4-FFF2-40B4-BE49-F238E27FC236}">
+                <a16:creationId xmlns:a16="http://schemas.microsoft.com/office/drawing/2014/main" id="{0A9B79D3-EB9A-B642-2D1C-34DA30F0AD76}"/>
+              </a:ext>
+            </a:extLst>
+          </p:cNvPr>
           <p:cNvSpPr>
             <a:spLocks noGrp="1"/>
           </p:cNvSpPr>
@@ -1254,82 +1333,59 @@
         </p:nvSpPr>
         <p:spPr>
           <a:xfrm>
-            <a:off x="4648200" y="1600200"/>
-            <a:ext cx="4038600" cy="4525963"/>
+            <a:off x="6172200" y="1825625"/>
+            <a:ext cx="5181600" cy="4351338"/>
           </a:xfrm>
         </p:spPr>
         <p:txBody>
           <a:bodyPr/>
-          <a:lstStyle>
-            <a:lvl1pPr>
-              <a:defRPr sz="2800"/>
-            </a:lvl1pPr>
-            <a:lvl2pPr>
-              <a:defRPr sz="2400"/>
-            </a:lvl2pPr>
-            <a:lvl3pPr>
-              <a:defRPr sz="2000"/>
-            </a:lvl3pPr>
-            <a:lvl4pPr>
-              <a:defRPr sz="1800"/>
-            </a:lvl4pPr>
-            <a:lvl5pPr>
-              <a:defRPr sz="1800"/>
-            </a:lvl5pPr>
-            <a:lvl6pPr>
-              <a:defRPr sz="1800"/>
-            </a:lvl6pPr>
-            <a:lvl7pPr>
-              <a:defRPr sz="1800"/>
-            </a:lvl7pPr>
-            <a:lvl8pPr>
-              <a:defRPr sz="1800"/>
-            </a:lvl8pPr>
-            <a:lvl9pPr>
-              <a:defRPr sz="1800"/>
-            </a:lvl9pPr>
-          </a:lstStyle>
+          <a:lstStyle/>
           <a:p>
             <a:pPr lvl="0"/>
             <a:r>
-              <a:rPr lang="en-US" smtClean="0"/>
-              <a:t>Click to edit Master text styles</a:t>
+              <a:rPr lang="pt-BR"/>
+              <a:t>Clique para editar os estilos de texto Mestres</a:t>
             </a:r>
           </a:p>
           <a:p>
             <a:pPr lvl="1"/>
             <a:r>
-              <a:rPr lang="en-US" smtClean="0"/>
-              <a:t>Second level</a:t>
+              <a:rPr lang="pt-BR"/>
+              <a:t>Segundo nível</a:t>
             </a:r>
           </a:p>
           <a:p>
             <a:pPr lvl="2"/>
             <a:r>
-              <a:rPr lang="en-US" smtClean="0"/>
-              <a:t>Third level</a:t>
+              <a:rPr lang="pt-BR"/>
+              <a:t>Terceiro nível</a:t>
             </a:r>
           </a:p>
           <a:p>
             <a:pPr lvl="3"/>
             <a:r>
-              <a:rPr lang="en-US" smtClean="0"/>
-              <a:t>Fourth level</a:t>
+              <a:rPr lang="pt-BR"/>
+              <a:t>Quarto nível</a:t>
             </a:r>
           </a:p>
           <a:p>
             <a:pPr lvl="4"/>
             <a:r>
-              <a:rPr lang="en-US" smtClean="0"/>
-              <a:t>Fifth level</a:t>
-            </a:r>
-            <a:endParaRPr lang="en-US"/>
-          </a:p>
-        </p:txBody>
-      </p:sp>
-      <p:sp>
-        <p:nvSpPr>
-          <p:cNvPr id="5" name="Date Placeholder 4"/>
+              <a:rPr lang="pt-BR"/>
+              <a:t>Quinto nível</a:t>
+            </a:r>
+          </a:p>
+        </p:txBody>
+      </p:sp>
+      <p:sp>
+        <p:nvSpPr>
+          <p:cNvPr id="5" name="Espaço Reservado para Data 4">
+            <a:extLst>
+              <a:ext uri="{FF2B5EF4-FFF2-40B4-BE49-F238E27FC236}">
+                <a16:creationId xmlns:a16="http://schemas.microsoft.com/office/drawing/2014/main" id="{6EFD5476-6632-F5BF-0DCC-462B5D2A233E}"/>
+              </a:ext>
+            </a:extLst>
+          </p:cNvPr>
           <p:cNvSpPr>
             <a:spLocks noGrp="1"/>
           </p:cNvSpPr>
@@ -1342,17 +1398,23 @@
           <a:bodyPr/>
           <a:lstStyle/>
           <a:p>
-            <a:fld id="{5BCAD085-E8A6-8845-BD4E-CB4CCA059FC4}" type="datetimeFigureOut">
-              <a:rPr lang="en-US" smtClean="0"/>
-              <a:t>1/27/13</a:t>
+            <a:fld id="{22C9067A-926A-4F91-B7AE-7AC6F651DD3F}" type="datetimeFigureOut">
+              <a:rPr lang="pt-BR" smtClean="0"/>
+              <a:t>06/07/2026</a:t>
             </a:fld>
-            <a:endParaRPr lang="en-US"/>
-          </a:p>
-        </p:txBody>
-      </p:sp>
-      <p:sp>
-        <p:nvSpPr>
-          <p:cNvPr id="6" name="Footer Placeholder 5"/>
+            <a:endParaRPr lang="pt-BR"/>
+          </a:p>
+        </p:txBody>
+      </p:sp>
+      <p:sp>
+        <p:nvSpPr>
+          <p:cNvPr id="6" name="Espaço Reservado para Rodapé 5">
+            <a:extLst>
+              <a:ext uri="{FF2B5EF4-FFF2-40B4-BE49-F238E27FC236}">
+                <a16:creationId xmlns:a16="http://schemas.microsoft.com/office/drawing/2014/main" id="{A969B75F-73DA-E314-BDFA-5E98B78F325C}"/>
+              </a:ext>
+            </a:extLst>
+          </p:cNvPr>
           <p:cNvSpPr>
             <a:spLocks noGrp="1"/>
           </p:cNvSpPr>
@@ -1365,13 +1427,19 @@
           <a:bodyPr/>
           <a:lstStyle/>
           <a:p>
-            <a:endParaRPr lang="en-US"/>
-          </a:p>
-        </p:txBody>
-      </p:sp>
-      <p:sp>
-        <p:nvSpPr>
-          <p:cNvPr id="7" name="Slide Number Placeholder 6"/>
+            <a:endParaRPr lang="pt-BR"/>
+          </a:p>
+        </p:txBody>
+      </p:sp>
+      <p:sp>
+        <p:nvSpPr>
+          <p:cNvPr id="7" name="Espaço Reservado para Número de Slide 6">
+            <a:extLst>
+              <a:ext uri="{FF2B5EF4-FFF2-40B4-BE49-F238E27FC236}">
+                <a16:creationId xmlns:a16="http://schemas.microsoft.com/office/drawing/2014/main" id="{27DB50A0-A26A-9633-3E3F-F990A16062A9}"/>
+              </a:ext>
+            </a:extLst>
+          </p:cNvPr>
           <p:cNvSpPr>
             <a:spLocks noGrp="1"/>
           </p:cNvSpPr>
@@ -1384,18 +1452,18 @@
           <a:bodyPr/>
           <a:lstStyle/>
           <a:p>
-            <a:fld id="{C1FF6DA9-008F-8B48-92A6-B652298478BF}" type="slidenum">
-              <a:rPr lang="en-US" smtClean="0"/>
-              <a:t>‹#›</a:t>
+            <a:fld id="{04F480B6-C421-4DC2-BA7E-81BCB3D20179}" type="slidenum">
+              <a:rPr lang="pt-BR" smtClean="0"/>
+              <a:t>‹nº›</a:t>
             </a:fld>
-            <a:endParaRPr lang="en-US"/>
+            <a:endParaRPr lang="pt-BR"/>
           </a:p>
         </p:txBody>
       </p:sp>
     </p:spTree>
     <p:extLst>
       <p:ext uri="{BB962C8B-B14F-4D97-AF65-F5344CB8AC3E}">
-        <p14:creationId xmlns:p14="http://schemas.microsoft.com/office/powerpoint/2010/main" val="2782244947"/>
+        <p14:creationId xmlns:p14="http://schemas.microsoft.com/office/powerpoint/2010/main" val="492873415"/>
       </p:ext>
     </p:extLst>
   </p:cSld>
@@ -1407,7 +1475,7 @@
 
 <file path=ppt/slideLayouts/slideLayout5.xml><?xml version="1.0" encoding="utf-8"?>
 <p:sldLayout xmlns:a="http://schemas.openxmlformats.org/drawingml/2006/main" xmlns:r="http://schemas.openxmlformats.org/officeDocument/2006/relationships" xmlns:p="http://schemas.openxmlformats.org/presentationml/2006/main" type="twoTxTwoObj" preserve="1">
-  <p:cSld name="Comparison">
+  <p:cSld name="Comparação">
     <p:spTree>
       <p:nvGrpSpPr>
         <p:cNvPr id="1" name=""/>
@@ -1424,45 +1492,57 @@
       </p:grpSpPr>
       <p:sp>
         <p:nvSpPr>
-          <p:cNvPr id="2" name="Title 1"/>
+          <p:cNvPr id="2" name="Título 1">
+            <a:extLst>
+              <a:ext uri="{FF2B5EF4-FFF2-40B4-BE49-F238E27FC236}">
+                <a16:creationId xmlns:a16="http://schemas.microsoft.com/office/drawing/2014/main" id="{94480D28-4EC9-0DBF-46DA-48739E2A069C}"/>
+              </a:ext>
+            </a:extLst>
+          </p:cNvPr>
           <p:cNvSpPr>
             <a:spLocks noGrp="1"/>
           </p:cNvSpPr>
           <p:nvPr>
             <p:ph type="title"/>
-          </p:nvPr>
-        </p:nvSpPr>
-        <p:spPr/>
-        <p:txBody>
-          <a:bodyPr/>
-          <a:lstStyle>
-            <a:lvl1pPr>
-              <a:defRPr/>
-            </a:lvl1pPr>
-          </a:lstStyle>
-          <a:p>
-            <a:r>
-              <a:rPr lang="en-US" smtClean="0"/>
-              <a:t>Click to edit Master title style</a:t>
-            </a:r>
-            <a:endParaRPr lang="en-US"/>
-          </a:p>
-        </p:txBody>
-      </p:sp>
-      <p:sp>
-        <p:nvSpPr>
-          <p:cNvPr id="3" name="Text Placeholder 2"/>
-          <p:cNvSpPr>
-            <a:spLocks noGrp="1"/>
-          </p:cNvSpPr>
-          <p:nvPr>
-            <p:ph type="body" idx="1"/>
           </p:nvPr>
         </p:nvSpPr>
         <p:spPr>
           <a:xfrm>
-            <a:off x="457200" y="1535113"/>
-            <a:ext cx="4040188" cy="639762"/>
+            <a:off x="839788" y="365125"/>
+            <a:ext cx="10515600" cy="1325563"/>
+          </a:xfrm>
+        </p:spPr>
+        <p:txBody>
+          <a:bodyPr/>
+          <a:lstStyle/>
+          <a:p>
+            <a:r>
+              <a:rPr lang="pt-BR"/>
+              <a:t>Clique para editar o título Mestre</a:t>
+            </a:r>
+          </a:p>
+        </p:txBody>
+      </p:sp>
+      <p:sp>
+        <p:nvSpPr>
+          <p:cNvPr id="3" name="Espaço Reservado para Texto 2">
+            <a:extLst>
+              <a:ext uri="{FF2B5EF4-FFF2-40B4-BE49-F238E27FC236}">
+                <a16:creationId xmlns:a16="http://schemas.microsoft.com/office/drawing/2014/main" id="{C2D7EB66-A4B4-7463-B043-2B09B2FB4434}"/>
+              </a:ext>
+            </a:extLst>
+          </p:cNvPr>
+          <p:cNvSpPr>
+            <a:spLocks noGrp="1"/>
+          </p:cNvSpPr>
+          <p:nvPr>
+            <p:ph type="body" idx="1"/>
+          </p:nvPr>
+        </p:nvSpPr>
+        <p:spPr>
+          <a:xfrm>
+            <a:off x="839788" y="1681163"/>
+            <a:ext cx="5157787" cy="823912"/>
           </a:xfrm>
         </p:spPr>
         <p:txBody>
@@ -1508,15 +1588,21 @@
           <a:p>
             <a:pPr lvl="0"/>
             <a:r>
-              <a:rPr lang="en-US" smtClean="0"/>
-              <a:t>Click to edit Master text styles</a:t>
-            </a:r>
-          </a:p>
-        </p:txBody>
-      </p:sp>
-      <p:sp>
-        <p:nvSpPr>
-          <p:cNvPr id="4" name="Content Placeholder 3"/>
+              <a:rPr lang="pt-BR"/>
+              <a:t>Clique para editar os estilos de texto Mestres</a:t>
+            </a:r>
+          </a:p>
+        </p:txBody>
+      </p:sp>
+      <p:sp>
+        <p:nvSpPr>
+          <p:cNvPr id="4" name="Espaço Reservado para Conteúdo 3">
+            <a:extLst>
+              <a:ext uri="{FF2B5EF4-FFF2-40B4-BE49-F238E27FC236}">
+                <a16:creationId xmlns:a16="http://schemas.microsoft.com/office/drawing/2014/main" id="{DA6DD331-7495-A74F-211A-D203EAF91B34}"/>
+              </a:ext>
+            </a:extLst>
+          </p:cNvPr>
           <p:cNvSpPr>
             <a:spLocks noGrp="1"/>
           </p:cNvSpPr>
@@ -1526,82 +1612,59 @@
         </p:nvSpPr>
         <p:spPr>
           <a:xfrm>
-            <a:off x="457200" y="2174875"/>
-            <a:ext cx="4040188" cy="3951288"/>
+            <a:off x="839788" y="2505075"/>
+            <a:ext cx="5157787" cy="3684588"/>
           </a:xfrm>
         </p:spPr>
         <p:txBody>
           <a:bodyPr/>
-          <a:lstStyle>
-            <a:lvl1pPr>
-              <a:defRPr sz="2400"/>
-            </a:lvl1pPr>
-            <a:lvl2pPr>
-              <a:defRPr sz="2000"/>
-            </a:lvl2pPr>
-            <a:lvl3pPr>
-              <a:defRPr sz="1800"/>
-            </a:lvl3pPr>
-            <a:lvl4pPr>
-              <a:defRPr sz="1600"/>
-            </a:lvl4pPr>
-            <a:lvl5pPr>
-              <a:defRPr sz="1600"/>
-            </a:lvl5pPr>
-            <a:lvl6pPr>
-              <a:defRPr sz="1600"/>
-            </a:lvl6pPr>
-            <a:lvl7pPr>
-              <a:defRPr sz="1600"/>
-            </a:lvl7pPr>
-            <a:lvl8pPr>
-              <a:defRPr sz="1600"/>
-            </a:lvl8pPr>
-            <a:lvl9pPr>
-              <a:defRPr sz="1600"/>
-            </a:lvl9pPr>
-          </a:lstStyle>
+          <a:lstStyle/>
           <a:p>
             <a:pPr lvl="0"/>
             <a:r>
-              <a:rPr lang="en-US" smtClean="0"/>
-              <a:t>Click to edit Master text styles</a:t>
+              <a:rPr lang="pt-BR"/>
+              <a:t>Clique para editar os estilos de texto Mestres</a:t>
             </a:r>
           </a:p>
           <a:p>
             <a:pPr lvl="1"/>
             <a:r>
-              <a:rPr lang="en-US" smtClean="0"/>
-              <a:t>Second level</a:t>
+              <a:rPr lang="pt-BR"/>
+              <a:t>Segundo nível</a:t>
             </a:r>
           </a:p>
           <a:p>
             <a:pPr lvl="2"/>
             <a:r>
-              <a:rPr lang="en-US" smtClean="0"/>
-              <a:t>Third level</a:t>
+              <a:rPr lang="pt-BR"/>
+              <a:t>Terceiro nível</a:t>
             </a:r>
           </a:p>
           <a:p>
             <a:pPr lvl="3"/>
             <a:r>
-              <a:rPr lang="en-US" smtClean="0"/>
-              <a:t>Fourth level</a:t>
+              <a:rPr lang="pt-BR"/>
+              <a:t>Quarto nível</a:t>
             </a:r>
           </a:p>
           <a:p>
             <a:pPr lvl="4"/>
             <a:r>
-              <a:rPr lang="en-US" smtClean="0"/>
-              <a:t>Fifth level</a:t>
-            </a:r>
-            <a:endParaRPr lang="en-US"/>
-          </a:p>
-        </p:txBody>
-      </p:sp>
-      <p:sp>
-        <p:nvSpPr>
-          <p:cNvPr id="5" name="Text Placeholder 4"/>
+              <a:rPr lang="pt-BR"/>
+              <a:t>Quinto nível</a:t>
+            </a:r>
+          </a:p>
+        </p:txBody>
+      </p:sp>
+      <p:sp>
+        <p:nvSpPr>
+          <p:cNvPr id="5" name="Espaço Reservado para Texto 4">
+            <a:extLst>
+              <a:ext uri="{FF2B5EF4-FFF2-40B4-BE49-F238E27FC236}">
+                <a16:creationId xmlns:a16="http://schemas.microsoft.com/office/drawing/2014/main" id="{CAB6218A-FF42-36EA-8451-5C14ACDB2310}"/>
+              </a:ext>
+            </a:extLst>
+          </p:cNvPr>
           <p:cNvSpPr>
             <a:spLocks noGrp="1"/>
           </p:cNvSpPr>
@@ -1611,8 +1674,8 @@
         </p:nvSpPr>
         <p:spPr>
           <a:xfrm>
-            <a:off x="4645025" y="1535113"/>
-            <a:ext cx="4041775" cy="639762"/>
+            <a:off x="6172200" y="1681163"/>
+            <a:ext cx="5183188" cy="823912"/>
           </a:xfrm>
         </p:spPr>
         <p:txBody>
@@ -1658,15 +1721,21 @@
           <a:p>
             <a:pPr lvl="0"/>
             <a:r>
-              <a:rPr lang="en-US" smtClean="0"/>
-              <a:t>Click to edit Master text styles</a:t>
-            </a:r>
-          </a:p>
-        </p:txBody>
-      </p:sp>
-      <p:sp>
-        <p:nvSpPr>
-          <p:cNvPr id="6" name="Content Placeholder 5"/>
+              <a:rPr lang="pt-BR"/>
+              <a:t>Clique para editar os estilos de texto Mestres</a:t>
+            </a:r>
+          </a:p>
+        </p:txBody>
+      </p:sp>
+      <p:sp>
+        <p:nvSpPr>
+          <p:cNvPr id="6" name="Espaço Reservado para Conteúdo 5">
+            <a:extLst>
+              <a:ext uri="{FF2B5EF4-FFF2-40B4-BE49-F238E27FC236}">
+                <a16:creationId xmlns:a16="http://schemas.microsoft.com/office/drawing/2014/main" id="{79991D7E-B2C1-26EB-0900-36E6560B63A4}"/>
+              </a:ext>
+            </a:extLst>
+          </p:cNvPr>
           <p:cNvSpPr>
             <a:spLocks noGrp="1"/>
           </p:cNvSpPr>
@@ -1676,82 +1745,59 @@
         </p:nvSpPr>
         <p:spPr>
           <a:xfrm>
-            <a:off x="4645025" y="2174875"/>
-            <a:ext cx="4041775" cy="3951288"/>
+            <a:off x="6172200" y="2505075"/>
+            <a:ext cx="5183188" cy="3684588"/>
           </a:xfrm>
         </p:spPr>
         <p:txBody>
           <a:bodyPr/>
-          <a:lstStyle>
-            <a:lvl1pPr>
-              <a:defRPr sz="2400"/>
-            </a:lvl1pPr>
-            <a:lvl2pPr>
-              <a:defRPr sz="2000"/>
-            </a:lvl2pPr>
-            <a:lvl3pPr>
-              <a:defRPr sz="1800"/>
-            </a:lvl3pPr>
-            <a:lvl4pPr>
-              <a:defRPr sz="1600"/>
-            </a:lvl4pPr>
-            <a:lvl5pPr>
-              <a:defRPr sz="1600"/>
-            </a:lvl5pPr>
-            <a:lvl6pPr>
-              <a:defRPr sz="1600"/>
-            </a:lvl6pPr>
-            <a:lvl7pPr>
-              <a:defRPr sz="1600"/>
-            </a:lvl7pPr>
-            <a:lvl8pPr>
-              <a:defRPr sz="1600"/>
-            </a:lvl8pPr>
-            <a:lvl9pPr>
-              <a:defRPr sz="1600"/>
-            </a:lvl9pPr>
-          </a:lstStyle>
+          <a:lstStyle/>
           <a:p>
             <a:pPr lvl="0"/>
             <a:r>
-              <a:rPr lang="en-US" smtClean="0"/>
-              <a:t>Click to edit Master text styles</a:t>
+              <a:rPr lang="pt-BR"/>
+              <a:t>Clique para editar os estilos de texto Mestres</a:t>
             </a:r>
           </a:p>
           <a:p>
             <a:pPr lvl="1"/>
             <a:r>
-              <a:rPr lang="en-US" smtClean="0"/>
-              <a:t>Second level</a:t>
+              <a:rPr lang="pt-BR"/>
+              <a:t>Segundo nível</a:t>
             </a:r>
           </a:p>
           <a:p>
             <a:pPr lvl="2"/>
             <a:r>
-              <a:rPr lang="en-US" smtClean="0"/>
-              <a:t>Third level</a:t>
+              <a:rPr lang="pt-BR"/>
+              <a:t>Terceiro nível</a:t>
             </a:r>
           </a:p>
           <a:p>
             <a:pPr lvl="3"/>
             <a:r>
-              <a:rPr lang="en-US" smtClean="0"/>
-              <a:t>Fourth level</a:t>
+              <a:rPr lang="pt-BR"/>
+              <a:t>Quarto nível</a:t>
             </a:r>
           </a:p>
           <a:p>
             <a:pPr lvl="4"/>
             <a:r>
-              <a:rPr lang="en-US" smtClean="0"/>
-              <a:t>Fifth level</a:t>
-            </a:r>
-            <a:endParaRPr lang="en-US"/>
-          </a:p>
-        </p:txBody>
-      </p:sp>
-      <p:sp>
-        <p:nvSpPr>
-          <p:cNvPr id="7" name="Date Placeholder 6"/>
+              <a:rPr lang="pt-BR"/>
+              <a:t>Quinto nível</a:t>
+            </a:r>
+          </a:p>
+        </p:txBody>
+      </p:sp>
+      <p:sp>
+        <p:nvSpPr>
+          <p:cNvPr id="7" name="Espaço Reservado para Data 6">
+            <a:extLst>
+              <a:ext uri="{FF2B5EF4-FFF2-40B4-BE49-F238E27FC236}">
+                <a16:creationId xmlns:a16="http://schemas.microsoft.com/office/drawing/2014/main" id="{399D4788-858F-DCF5-7ECB-A1A99880D01A}"/>
+              </a:ext>
+            </a:extLst>
+          </p:cNvPr>
           <p:cNvSpPr>
             <a:spLocks noGrp="1"/>
           </p:cNvSpPr>
@@ -1764,17 +1810,23 @@
           <a:bodyPr/>
           <a:lstStyle/>
           <a:p>
-            <a:fld id="{5BCAD085-E8A6-8845-BD4E-CB4CCA059FC4}" type="datetimeFigureOut">
-              <a:rPr lang="en-US" smtClean="0"/>
-              <a:t>1/27/13</a:t>
+            <a:fld id="{22C9067A-926A-4F91-B7AE-7AC6F651DD3F}" type="datetimeFigureOut">
+              <a:rPr lang="pt-BR" smtClean="0"/>
+              <a:t>06/07/2026</a:t>
             </a:fld>
-            <a:endParaRPr lang="en-US"/>
-          </a:p>
-        </p:txBody>
-      </p:sp>
-      <p:sp>
-        <p:nvSpPr>
-          <p:cNvPr id="8" name="Footer Placeholder 7"/>
+            <a:endParaRPr lang="pt-BR"/>
+          </a:p>
+        </p:txBody>
+      </p:sp>
+      <p:sp>
+        <p:nvSpPr>
+          <p:cNvPr id="8" name="Espaço Reservado para Rodapé 7">
+            <a:extLst>
+              <a:ext uri="{FF2B5EF4-FFF2-40B4-BE49-F238E27FC236}">
+                <a16:creationId xmlns:a16="http://schemas.microsoft.com/office/drawing/2014/main" id="{09135E27-AEF9-CE1E-DE8A-5336230B0B60}"/>
+              </a:ext>
+            </a:extLst>
+          </p:cNvPr>
           <p:cNvSpPr>
             <a:spLocks noGrp="1"/>
           </p:cNvSpPr>
@@ -1787,13 +1839,19 @@
           <a:bodyPr/>
           <a:lstStyle/>
           <a:p>
-            <a:endParaRPr lang="en-US"/>
-          </a:p>
-        </p:txBody>
-      </p:sp>
-      <p:sp>
-        <p:nvSpPr>
-          <p:cNvPr id="9" name="Slide Number Placeholder 8"/>
+            <a:endParaRPr lang="pt-BR"/>
+          </a:p>
+        </p:txBody>
+      </p:sp>
+      <p:sp>
+        <p:nvSpPr>
+          <p:cNvPr id="9" name="Espaço Reservado para Número de Slide 8">
+            <a:extLst>
+              <a:ext uri="{FF2B5EF4-FFF2-40B4-BE49-F238E27FC236}">
+                <a16:creationId xmlns:a16="http://schemas.microsoft.com/office/drawing/2014/main" id="{46F8A639-F4A6-62C7-4EBA-95638F12DF20}"/>
+              </a:ext>
+            </a:extLst>
+          </p:cNvPr>
           <p:cNvSpPr>
             <a:spLocks noGrp="1"/>
           </p:cNvSpPr>
@@ -1806,18 +1864,18 @@
           <a:bodyPr/>
           <a:lstStyle/>
           <a:p>
-            <a:fld id="{C1FF6DA9-008F-8B48-92A6-B652298478BF}" type="slidenum">
-              <a:rPr lang="en-US" smtClean="0"/>
-              <a:t>‹#›</a:t>
+            <a:fld id="{04F480B6-C421-4DC2-BA7E-81BCB3D20179}" type="slidenum">
+              <a:rPr lang="pt-BR" smtClean="0"/>
+              <a:t>‹nº›</a:t>
             </a:fld>
-            <a:endParaRPr lang="en-US"/>
+            <a:endParaRPr lang="pt-BR"/>
           </a:p>
         </p:txBody>
       </p:sp>
     </p:spTree>
     <p:extLst>
       <p:ext uri="{BB962C8B-B14F-4D97-AF65-F5344CB8AC3E}">
-        <p14:creationId xmlns:p14="http://schemas.microsoft.com/office/powerpoint/2010/main" val="990158736"/>
+        <p14:creationId xmlns:p14="http://schemas.microsoft.com/office/powerpoint/2010/main" val="1529216903"/>
       </p:ext>
     </p:extLst>
   </p:cSld>
@@ -1829,7 +1887,7 @@
 
 <file path=ppt/slideLayouts/slideLayout6.xml><?xml version="1.0" encoding="utf-8"?>
 <p:sldLayout xmlns:a="http://schemas.openxmlformats.org/drawingml/2006/main" xmlns:r="http://schemas.openxmlformats.org/officeDocument/2006/relationships" xmlns:p="http://schemas.openxmlformats.org/presentationml/2006/main" type="titleOnly" preserve="1">
-  <p:cSld name="Title Only">
+  <p:cSld name="Somente Título">
     <p:spTree>
       <p:nvGrpSpPr>
         <p:cNvPr id="1" name=""/>
@@ -1846,7 +1904,13 @@
       </p:grpSpPr>
       <p:sp>
         <p:nvSpPr>
-          <p:cNvPr id="2" name="Title 1"/>
+          <p:cNvPr id="2" name="Título 1">
+            <a:extLst>
+              <a:ext uri="{FF2B5EF4-FFF2-40B4-BE49-F238E27FC236}">
+                <a16:creationId xmlns:a16="http://schemas.microsoft.com/office/drawing/2014/main" id="{CA32685A-E91D-753B-600B-C53D6878E21D}"/>
+              </a:ext>
+            </a:extLst>
+          </p:cNvPr>
           <p:cNvSpPr>
             <a:spLocks noGrp="1"/>
           </p:cNvSpPr>
@@ -1860,16 +1924,21 @@
           <a:lstStyle/>
           <a:p>
             <a:r>
-              <a:rPr lang="en-US" smtClean="0"/>
-              <a:t>Click to edit Master title style</a:t>
-            </a:r>
-            <a:endParaRPr lang="en-US"/>
-          </a:p>
-        </p:txBody>
-      </p:sp>
-      <p:sp>
-        <p:nvSpPr>
-          <p:cNvPr id="3" name="Date Placeholder 2"/>
+              <a:rPr lang="pt-BR"/>
+              <a:t>Clique para editar o título Mestre</a:t>
+            </a:r>
+          </a:p>
+        </p:txBody>
+      </p:sp>
+      <p:sp>
+        <p:nvSpPr>
+          <p:cNvPr id="3" name="Espaço Reservado para Data 2">
+            <a:extLst>
+              <a:ext uri="{FF2B5EF4-FFF2-40B4-BE49-F238E27FC236}">
+                <a16:creationId xmlns:a16="http://schemas.microsoft.com/office/drawing/2014/main" id="{881A0063-42FA-AC0B-55B2-0BBDDDC9C8B2}"/>
+              </a:ext>
+            </a:extLst>
+          </p:cNvPr>
           <p:cNvSpPr>
             <a:spLocks noGrp="1"/>
           </p:cNvSpPr>
@@ -1882,17 +1951,23 @@
           <a:bodyPr/>
           <a:lstStyle/>
           <a:p>
-            <a:fld id="{5BCAD085-E8A6-8845-BD4E-CB4CCA059FC4}" type="datetimeFigureOut">
-              <a:rPr lang="en-US" smtClean="0"/>
-              <a:t>1/27/13</a:t>
+            <a:fld id="{22C9067A-926A-4F91-B7AE-7AC6F651DD3F}" type="datetimeFigureOut">
+              <a:rPr lang="pt-BR" smtClean="0"/>
+              <a:t>06/07/2026</a:t>
             </a:fld>
-            <a:endParaRPr lang="en-US"/>
-          </a:p>
-        </p:txBody>
-      </p:sp>
-      <p:sp>
-        <p:nvSpPr>
-          <p:cNvPr id="4" name="Footer Placeholder 3"/>
+            <a:endParaRPr lang="pt-BR"/>
+          </a:p>
+        </p:txBody>
+      </p:sp>
+      <p:sp>
+        <p:nvSpPr>
+          <p:cNvPr id="4" name="Espaço Reservado para Rodapé 3">
+            <a:extLst>
+              <a:ext uri="{FF2B5EF4-FFF2-40B4-BE49-F238E27FC236}">
+                <a16:creationId xmlns:a16="http://schemas.microsoft.com/office/drawing/2014/main" id="{2D326951-B1DC-2795-4800-1166D28B0377}"/>
+              </a:ext>
+            </a:extLst>
+          </p:cNvPr>
           <p:cNvSpPr>
             <a:spLocks noGrp="1"/>
           </p:cNvSpPr>
@@ -1905,13 +1980,19 @@
           <a:bodyPr/>
           <a:lstStyle/>
           <a:p>
-            <a:endParaRPr lang="en-US"/>
-          </a:p>
-        </p:txBody>
-      </p:sp>
-      <p:sp>
-        <p:nvSpPr>
-          <p:cNvPr id="5" name="Slide Number Placeholder 4"/>
+            <a:endParaRPr lang="pt-BR"/>
+          </a:p>
+        </p:txBody>
+      </p:sp>
+      <p:sp>
+        <p:nvSpPr>
+          <p:cNvPr id="5" name="Espaço Reservado para Número de Slide 4">
+            <a:extLst>
+              <a:ext uri="{FF2B5EF4-FFF2-40B4-BE49-F238E27FC236}">
+                <a16:creationId xmlns:a16="http://schemas.microsoft.com/office/drawing/2014/main" id="{7DFE6777-229F-DEA0-3BA2-BEDAEDB38537}"/>
+              </a:ext>
+            </a:extLst>
+          </p:cNvPr>
           <p:cNvSpPr>
             <a:spLocks noGrp="1"/>
           </p:cNvSpPr>
@@ -1924,18 +2005,18 @@
           <a:bodyPr/>
           <a:lstStyle/>
           <a:p>
-            <a:fld id="{C1FF6DA9-008F-8B48-92A6-B652298478BF}" type="slidenum">
-              <a:rPr lang="en-US" smtClean="0"/>
-              <a:t>‹#›</a:t>
+            <a:fld id="{04F480B6-C421-4DC2-BA7E-81BCB3D20179}" type="slidenum">
+              <a:rPr lang="pt-BR" smtClean="0"/>
+              <a:t>‹nº›</a:t>
             </a:fld>
-            <a:endParaRPr lang="en-US"/>
+            <a:endParaRPr lang="pt-BR"/>
           </a:p>
         </p:txBody>
       </p:sp>
     </p:spTree>
     <p:extLst>
       <p:ext uri="{BB962C8B-B14F-4D97-AF65-F5344CB8AC3E}">
-        <p14:creationId xmlns:p14="http://schemas.microsoft.com/office/powerpoint/2010/main" val="727027711"/>
+        <p14:creationId xmlns:p14="http://schemas.microsoft.com/office/powerpoint/2010/main" val="584470499"/>
       </p:ext>
     </p:extLst>
   </p:cSld>
@@ -1947,7 +2028,7 @@
 
 <file path=ppt/slideLayouts/slideLayout7.xml><?xml version="1.0" encoding="utf-8"?>
 <p:sldLayout xmlns:a="http://schemas.openxmlformats.org/drawingml/2006/main" xmlns:r="http://schemas.openxmlformats.org/officeDocument/2006/relationships" xmlns:p="http://schemas.openxmlformats.org/presentationml/2006/main" type="blank" preserve="1">
-  <p:cSld name="Blank">
+  <p:cSld name="Em Branco">
     <p:spTree>
       <p:nvGrpSpPr>
         <p:cNvPr id="1" name=""/>
@@ -1964,7 +2045,13 @@
       </p:grpSpPr>
       <p:sp>
         <p:nvSpPr>
-          <p:cNvPr id="2" name="Date Placeholder 1"/>
+          <p:cNvPr id="2" name="Espaço Reservado para Data 1">
+            <a:extLst>
+              <a:ext uri="{FF2B5EF4-FFF2-40B4-BE49-F238E27FC236}">
+                <a16:creationId xmlns:a16="http://schemas.microsoft.com/office/drawing/2014/main" id="{532629D6-647D-82EC-81AD-3A982FAA9213}"/>
+              </a:ext>
+            </a:extLst>
+          </p:cNvPr>
           <p:cNvSpPr>
             <a:spLocks noGrp="1"/>
           </p:cNvSpPr>
@@ -1977,17 +2064,23 @@
           <a:bodyPr/>
           <a:lstStyle/>
           <a:p>
-            <a:fld id="{5BCAD085-E8A6-8845-BD4E-CB4CCA059FC4}" type="datetimeFigureOut">
-              <a:rPr lang="en-US" smtClean="0"/>
-              <a:t>1/27/13</a:t>
+            <a:fld id="{22C9067A-926A-4F91-B7AE-7AC6F651DD3F}" type="datetimeFigureOut">
+              <a:rPr lang="pt-BR" smtClean="0"/>
+              <a:t>06/07/2026</a:t>
             </a:fld>
-            <a:endParaRPr lang="en-US"/>
-          </a:p>
-        </p:txBody>
-      </p:sp>
-      <p:sp>
-        <p:nvSpPr>
-          <p:cNvPr id="3" name="Footer Placeholder 2"/>
+            <a:endParaRPr lang="pt-BR"/>
+          </a:p>
+        </p:txBody>
+      </p:sp>
+      <p:sp>
+        <p:nvSpPr>
+          <p:cNvPr id="3" name="Espaço Reservado para Rodapé 2">
+            <a:extLst>
+              <a:ext uri="{FF2B5EF4-FFF2-40B4-BE49-F238E27FC236}">
+                <a16:creationId xmlns:a16="http://schemas.microsoft.com/office/drawing/2014/main" id="{FF891322-DC86-2CC5-763C-E512155F019B}"/>
+              </a:ext>
+            </a:extLst>
+          </p:cNvPr>
           <p:cNvSpPr>
             <a:spLocks noGrp="1"/>
           </p:cNvSpPr>
@@ -2000,13 +2093,19 @@
           <a:bodyPr/>
           <a:lstStyle/>
           <a:p>
-            <a:endParaRPr lang="en-US"/>
-          </a:p>
-        </p:txBody>
-      </p:sp>
-      <p:sp>
-        <p:nvSpPr>
-          <p:cNvPr id="4" name="Slide Number Placeholder 3"/>
+            <a:endParaRPr lang="pt-BR"/>
+          </a:p>
+        </p:txBody>
+      </p:sp>
+      <p:sp>
+        <p:nvSpPr>
+          <p:cNvPr id="4" name="Espaço Reservado para Número de Slide 3">
+            <a:extLst>
+              <a:ext uri="{FF2B5EF4-FFF2-40B4-BE49-F238E27FC236}">
+                <a16:creationId xmlns:a16="http://schemas.microsoft.com/office/drawing/2014/main" id="{B31EEE7E-FB7F-D5CB-227E-012233A893C3}"/>
+              </a:ext>
+            </a:extLst>
+          </p:cNvPr>
           <p:cNvSpPr>
             <a:spLocks noGrp="1"/>
           </p:cNvSpPr>
@@ -2019,18 +2118,18 @@
           <a:bodyPr/>
           <a:lstStyle/>
           <a:p>
-            <a:fld id="{C1FF6DA9-008F-8B48-92A6-B652298478BF}" type="slidenum">
-              <a:rPr lang="en-US" smtClean="0"/>
-              <a:t>‹#›</a:t>
+            <a:fld id="{04F480B6-C421-4DC2-BA7E-81BCB3D20179}" type="slidenum">
+              <a:rPr lang="pt-BR" smtClean="0"/>
+              <a:t>‹nº›</a:t>
             </a:fld>
-            <a:endParaRPr lang="en-US"/>
+            <a:endParaRPr lang="pt-BR"/>
           </a:p>
         </p:txBody>
       </p:sp>
     </p:spTree>
     <p:extLst>
       <p:ext uri="{BB962C8B-B14F-4D97-AF65-F5344CB8AC3E}">
-        <p14:creationId xmlns:p14="http://schemas.microsoft.com/office/powerpoint/2010/main" val="1212999818"/>
+        <p14:creationId xmlns:p14="http://schemas.microsoft.com/office/powerpoint/2010/main" val="914064936"/>
       </p:ext>
     </p:extLst>
   </p:cSld>
@@ -2042,7 +2141,7 @@
 
 <file path=ppt/slideLayouts/slideLayout8.xml><?xml version="1.0" encoding="utf-8"?>
 <p:sldLayout xmlns:a="http://schemas.openxmlformats.org/drawingml/2006/main" xmlns:r="http://schemas.openxmlformats.org/officeDocument/2006/relationships" xmlns:p="http://schemas.openxmlformats.org/presentationml/2006/main" type="objTx" preserve="1">
-  <p:cSld name="Content with Caption">
+  <p:cSld name="Conteúdo com Legenda">
     <p:spTree>
       <p:nvGrpSpPr>
         <p:cNvPr id="1" name=""/>
@@ -2059,7 +2158,13 @@
       </p:grpSpPr>
       <p:sp>
         <p:nvSpPr>
-          <p:cNvPr id="2" name="Title 1"/>
+          <p:cNvPr id="2" name="Título 1">
+            <a:extLst>
+              <a:ext uri="{FF2B5EF4-FFF2-40B4-BE49-F238E27FC236}">
+                <a16:creationId xmlns:a16="http://schemas.microsoft.com/office/drawing/2014/main" id="{17D08290-94C3-A22A-641A-0AEF0C265AF3}"/>
+              </a:ext>
+            </a:extLst>
+          </p:cNvPr>
           <p:cNvSpPr>
             <a:spLocks noGrp="1"/>
           </p:cNvSpPr>
@@ -2069,29 +2174,34 @@
         </p:nvSpPr>
         <p:spPr>
           <a:xfrm>
-            <a:off x="457200" y="273050"/>
-            <a:ext cx="3008313" cy="1162050"/>
+            <a:off x="839788" y="457200"/>
+            <a:ext cx="3932237" cy="1600200"/>
           </a:xfrm>
         </p:spPr>
         <p:txBody>
           <a:bodyPr anchor="b"/>
           <a:lstStyle>
-            <a:lvl1pPr algn="l">
-              <a:defRPr sz="2000" b="1"/>
+            <a:lvl1pPr>
+              <a:defRPr sz="3200"/>
             </a:lvl1pPr>
           </a:lstStyle>
           <a:p>
             <a:r>
-              <a:rPr lang="en-US" smtClean="0"/>
-              <a:t>Click to edit Master title style</a:t>
-            </a:r>
-            <a:endParaRPr lang="en-US"/>
-          </a:p>
-        </p:txBody>
-      </p:sp>
-      <p:sp>
-        <p:nvSpPr>
-          <p:cNvPr id="3" name="Content Placeholder 2"/>
+              <a:rPr lang="pt-BR"/>
+              <a:t>Clique para editar o título Mestre</a:t>
+            </a:r>
+          </a:p>
+        </p:txBody>
+      </p:sp>
+      <p:sp>
+        <p:nvSpPr>
+          <p:cNvPr id="3" name="Espaço Reservado para Conteúdo 2">
+            <a:extLst>
+              <a:ext uri="{FF2B5EF4-FFF2-40B4-BE49-F238E27FC236}">
+                <a16:creationId xmlns:a16="http://schemas.microsoft.com/office/drawing/2014/main" id="{40C70F9C-13BB-4F5E-EA27-AC91EA293F4B}"/>
+              </a:ext>
+            </a:extLst>
+          </p:cNvPr>
           <p:cNvSpPr>
             <a:spLocks noGrp="1"/>
           </p:cNvSpPr>
@@ -2101,8 +2211,8 @@
         </p:nvSpPr>
         <p:spPr>
           <a:xfrm>
-            <a:off x="3575050" y="273050"/>
-            <a:ext cx="5111750" cy="5853113"/>
+            <a:off x="5183188" y="987425"/>
+            <a:ext cx="6172200" cy="4873625"/>
           </a:xfrm>
         </p:spPr>
         <p:txBody>
@@ -2139,44 +2249,49 @@
           <a:p>
             <a:pPr lvl="0"/>
             <a:r>
-              <a:rPr lang="en-US" smtClean="0"/>
-              <a:t>Click to edit Master text styles</a:t>
+              <a:rPr lang="pt-BR"/>
+              <a:t>Clique para editar os estilos de texto Mestres</a:t>
             </a:r>
           </a:p>
           <a:p>
             <a:pPr lvl="1"/>
             <a:r>
-              <a:rPr lang="en-US" smtClean="0"/>
-              <a:t>Second level</a:t>
+              <a:rPr lang="pt-BR"/>
+              <a:t>Segundo nível</a:t>
             </a:r>
           </a:p>
           <a:p>
             <a:pPr lvl="2"/>
             <a:r>
-              <a:rPr lang="en-US" smtClean="0"/>
-              <a:t>Third level</a:t>
+              <a:rPr lang="pt-BR"/>
+              <a:t>Terceiro nível</a:t>
             </a:r>
           </a:p>
           <a:p>
             <a:pPr lvl="3"/>
             <a:r>
-              <a:rPr lang="en-US" smtClean="0"/>
-              <a:t>Fourth level</a:t>
+              <a:rPr lang="pt-BR"/>
+              <a:t>Quarto nível</a:t>
             </a:r>
           </a:p>
           <a:p>
             <a:pPr lvl="4"/>
             <a:r>
-              <a:rPr lang="en-US" smtClean="0"/>
-              <a:t>Fifth level</a:t>
-            </a:r>
-            <a:endParaRPr lang="en-US"/>
-          </a:p>
-        </p:txBody>
-      </p:sp>
-      <p:sp>
-        <p:nvSpPr>
-          <p:cNvPr id="4" name="Text Placeholder 3"/>
+              <a:rPr lang="pt-BR"/>
+              <a:t>Quinto nível</a:t>
+            </a:r>
+          </a:p>
+        </p:txBody>
+      </p:sp>
+      <p:sp>
+        <p:nvSpPr>
+          <p:cNvPr id="4" name="Espaço Reservado para Texto 3">
+            <a:extLst>
+              <a:ext uri="{FF2B5EF4-FFF2-40B4-BE49-F238E27FC236}">
+                <a16:creationId xmlns:a16="http://schemas.microsoft.com/office/drawing/2014/main" id="{CE5AF7AC-23DD-BEDF-CD4D-4D2FD229F505}"/>
+              </a:ext>
+            </a:extLst>
+          </p:cNvPr>
           <p:cNvSpPr>
             <a:spLocks noGrp="1"/>
           </p:cNvSpPr>
@@ -2186,8 +2301,8 @@
         </p:nvSpPr>
         <p:spPr>
           <a:xfrm>
-            <a:off x="457200" y="1435100"/>
-            <a:ext cx="3008313" cy="4691063"/>
+            <a:off x="839788" y="2057400"/>
+            <a:ext cx="3932237" cy="3811588"/>
           </a:xfrm>
         </p:spPr>
         <p:txBody>
@@ -2195,53 +2310,59 @@
           <a:lstStyle>
             <a:lvl1pPr marL="0" indent="0">
               <a:buNone/>
-              <a:defRPr sz="1400"/>
+              <a:defRPr sz="1600"/>
             </a:lvl1pPr>
             <a:lvl2pPr marL="457200" indent="0">
               <a:buNone/>
-              <a:defRPr sz="1200"/>
+              <a:defRPr sz="1400"/>
             </a:lvl2pPr>
             <a:lvl3pPr marL="914400" indent="0">
               <a:buNone/>
-              <a:defRPr sz="1000"/>
+              <a:defRPr sz="1200"/>
             </a:lvl3pPr>
             <a:lvl4pPr marL="1371600" indent="0">
               <a:buNone/>
-              <a:defRPr sz="900"/>
+              <a:defRPr sz="1000"/>
             </a:lvl4pPr>
             <a:lvl5pPr marL="1828800" indent="0">
               <a:buNone/>
-              <a:defRPr sz="900"/>
+              <a:defRPr sz="1000"/>
             </a:lvl5pPr>
             <a:lvl6pPr marL="2286000" indent="0">
               <a:buNone/>
-              <a:defRPr sz="900"/>
+              <a:defRPr sz="1000"/>
             </a:lvl6pPr>
             <a:lvl7pPr marL="2743200" indent="0">
               <a:buNone/>
-              <a:defRPr sz="900"/>
+              <a:defRPr sz="1000"/>
             </a:lvl7pPr>
             <a:lvl8pPr marL="3200400" indent="0">
               <a:buNone/>
-              <a:defRPr sz="900"/>
+              <a:defRPr sz="1000"/>
             </a:lvl8pPr>
             <a:lvl9pPr marL="3657600" indent="0">
               <a:buNone/>
-              <a:defRPr sz="900"/>
+              <a:defRPr sz="1000"/>
             </a:lvl9pPr>
           </a:lstStyle>
           <a:p>
             <a:pPr lvl="0"/>
             <a:r>
-              <a:rPr lang="en-US" smtClean="0"/>
-              <a:t>Click to edit Master text styles</a:t>
-            </a:r>
-          </a:p>
-        </p:txBody>
-      </p:sp>
-      <p:sp>
-        <p:nvSpPr>
-          <p:cNvPr id="5" name="Date Placeholder 4"/>
+              <a:rPr lang="pt-BR"/>
+              <a:t>Clique para editar os estilos de texto Mestres</a:t>
+            </a:r>
+          </a:p>
+        </p:txBody>
+      </p:sp>
+      <p:sp>
+        <p:nvSpPr>
+          <p:cNvPr id="5" name="Espaço Reservado para Data 4">
+            <a:extLst>
+              <a:ext uri="{FF2B5EF4-FFF2-40B4-BE49-F238E27FC236}">
+                <a16:creationId xmlns:a16="http://schemas.microsoft.com/office/drawing/2014/main" id="{97F868E3-09AC-A00F-2449-A00818DF31C3}"/>
+              </a:ext>
+            </a:extLst>
+          </p:cNvPr>
           <p:cNvSpPr>
             <a:spLocks noGrp="1"/>
           </p:cNvSpPr>
@@ -2254,17 +2375,23 @@
           <a:bodyPr/>
           <a:lstStyle/>
           <a:p>
-            <a:fld id="{5BCAD085-E8A6-8845-BD4E-CB4CCA059FC4}" type="datetimeFigureOut">
-              <a:rPr lang="en-US" smtClean="0"/>
-              <a:t>1/27/13</a:t>
+            <a:fld id="{22C9067A-926A-4F91-B7AE-7AC6F651DD3F}" type="datetimeFigureOut">
+              <a:rPr lang="pt-BR" smtClean="0"/>
+              <a:t>06/07/2026</a:t>
             </a:fld>
-            <a:endParaRPr lang="en-US"/>
-          </a:p>
-        </p:txBody>
-      </p:sp>
-      <p:sp>
-        <p:nvSpPr>
-          <p:cNvPr id="6" name="Footer Placeholder 5"/>
+            <a:endParaRPr lang="pt-BR"/>
+          </a:p>
+        </p:txBody>
+      </p:sp>
+      <p:sp>
+        <p:nvSpPr>
+          <p:cNvPr id="6" name="Espaço Reservado para Rodapé 5">
+            <a:extLst>
+              <a:ext uri="{FF2B5EF4-FFF2-40B4-BE49-F238E27FC236}">
+                <a16:creationId xmlns:a16="http://schemas.microsoft.com/office/drawing/2014/main" id="{F3633B1F-8806-BA4A-FD88-B867149357B6}"/>
+              </a:ext>
+            </a:extLst>
+          </p:cNvPr>
           <p:cNvSpPr>
             <a:spLocks noGrp="1"/>
           </p:cNvSpPr>
@@ -2277,13 +2404,19 @@
           <a:bodyPr/>
           <a:lstStyle/>
           <a:p>
-            <a:endParaRPr lang="en-US"/>
-          </a:p>
-        </p:txBody>
-      </p:sp>
-      <p:sp>
-        <p:nvSpPr>
-          <p:cNvPr id="7" name="Slide Number Placeholder 6"/>
+            <a:endParaRPr lang="pt-BR"/>
+          </a:p>
+        </p:txBody>
+      </p:sp>
+      <p:sp>
+        <p:nvSpPr>
+          <p:cNvPr id="7" name="Espaço Reservado para Número de Slide 6">
+            <a:extLst>
+              <a:ext uri="{FF2B5EF4-FFF2-40B4-BE49-F238E27FC236}">
+                <a16:creationId xmlns:a16="http://schemas.microsoft.com/office/drawing/2014/main" id="{7FA48CDA-7BC8-9BE3-4B9A-2D65AD9D3FF4}"/>
+              </a:ext>
+            </a:extLst>
+          </p:cNvPr>
           <p:cNvSpPr>
             <a:spLocks noGrp="1"/>
           </p:cNvSpPr>
@@ -2296,18 +2429,18 @@
           <a:bodyPr/>
           <a:lstStyle/>
           <a:p>
-            <a:fld id="{C1FF6DA9-008F-8B48-92A6-B652298478BF}" type="slidenum">
-              <a:rPr lang="en-US" smtClean="0"/>
-              <a:t>‹#›</a:t>
+            <a:fld id="{04F480B6-C421-4DC2-BA7E-81BCB3D20179}" type="slidenum">
+              <a:rPr lang="pt-BR" smtClean="0"/>
+              <a:t>‹nº›</a:t>
             </a:fld>
-            <a:endParaRPr lang="en-US"/>
+            <a:endParaRPr lang="pt-BR"/>
           </a:p>
         </p:txBody>
       </p:sp>
     </p:spTree>
     <p:extLst>
       <p:ext uri="{BB962C8B-B14F-4D97-AF65-F5344CB8AC3E}">
-        <p14:creationId xmlns:p14="http://schemas.microsoft.com/office/powerpoint/2010/main" val="1840726560"/>
+        <p14:creationId xmlns:p14="http://schemas.microsoft.com/office/powerpoint/2010/main" val="142103881"/>
       </p:ext>
     </p:extLst>
   </p:cSld>
@@ -2319,7 +2452,7 @@
 
 <file path=ppt/slideLayouts/slideLayout9.xml><?xml version="1.0" encoding="utf-8"?>
 <p:sldLayout xmlns:a="http://schemas.openxmlformats.org/drawingml/2006/main" xmlns:r="http://schemas.openxmlformats.org/officeDocument/2006/relationships" xmlns:p="http://schemas.openxmlformats.org/presentationml/2006/main" type="picTx" preserve="1">
-  <p:cSld name="Picture with Caption">
+  <p:cSld name="Imagem com Legenda">
     <p:spTree>
       <p:nvGrpSpPr>
         <p:cNvPr id="1" name=""/>
@@ -2336,7 +2469,13 @@
       </p:grpSpPr>
       <p:sp>
         <p:nvSpPr>
-          <p:cNvPr id="2" name="Title 1"/>
+          <p:cNvPr id="2" name="Título 1">
+            <a:extLst>
+              <a:ext uri="{FF2B5EF4-FFF2-40B4-BE49-F238E27FC236}">
+                <a16:creationId xmlns:a16="http://schemas.microsoft.com/office/drawing/2014/main" id="{DCA5CEBB-F5EB-F4CC-FFBC-19F5A6F791D2}"/>
+              </a:ext>
+            </a:extLst>
+          </p:cNvPr>
           <p:cNvSpPr>
             <a:spLocks noGrp="1"/>
           </p:cNvSpPr>
@@ -2346,29 +2485,34 @@
         </p:nvSpPr>
         <p:spPr>
           <a:xfrm>
-            <a:off x="1792288" y="4800600"/>
-            <a:ext cx="5486400" cy="566738"/>
+            <a:off x="839788" y="457200"/>
+            <a:ext cx="3932237" cy="1600200"/>
           </a:xfrm>
         </p:spPr>
         <p:txBody>
           <a:bodyPr anchor="b"/>
           <a:lstStyle>
-            <a:lvl1pPr algn="l">
-              <a:defRPr sz="2000" b="1"/>
+            <a:lvl1pPr>
+              <a:defRPr sz="3200"/>
             </a:lvl1pPr>
           </a:lstStyle>
           <a:p>
             <a:r>
-              <a:rPr lang="en-US" smtClean="0"/>
-              <a:t>Click to edit Master title style</a:t>
-            </a:r>
-            <a:endParaRPr lang="en-US"/>
-          </a:p>
-        </p:txBody>
-      </p:sp>
-      <p:sp>
-        <p:nvSpPr>
-          <p:cNvPr id="3" name="Picture Placeholder 2"/>
+              <a:rPr lang="pt-BR"/>
+              <a:t>Clique para editar o título Mestre</a:t>
+            </a:r>
+          </a:p>
+        </p:txBody>
+      </p:sp>
+      <p:sp>
+        <p:nvSpPr>
+          <p:cNvPr id="3" name="Espaço Reservado para Imagem 2">
+            <a:extLst>
+              <a:ext uri="{FF2B5EF4-FFF2-40B4-BE49-F238E27FC236}">
+                <a16:creationId xmlns:a16="http://schemas.microsoft.com/office/drawing/2014/main" id="{FF8858C5-C07A-BC2A-636B-19E0A728CEC7}"/>
+              </a:ext>
+            </a:extLst>
+          </p:cNvPr>
           <p:cNvSpPr>
             <a:spLocks noGrp="1"/>
           </p:cNvSpPr>
@@ -2378,8 +2522,8 @@
         </p:nvSpPr>
         <p:spPr>
           <a:xfrm>
-            <a:off x="1792288" y="612775"/>
-            <a:ext cx="5486400" cy="4114800"/>
+            <a:off x="5183188" y="987425"/>
+            <a:ext cx="6172200" cy="4873625"/>
           </a:xfrm>
         </p:spPr>
         <p:txBody>
@@ -2423,13 +2567,19 @@
             </a:lvl9pPr>
           </a:lstStyle>
           <a:p>
-            <a:endParaRPr lang="en-US"/>
-          </a:p>
-        </p:txBody>
-      </p:sp>
-      <p:sp>
-        <p:nvSpPr>
-          <p:cNvPr id="4" name="Text Placeholder 3"/>
+            <a:endParaRPr lang="pt-BR"/>
+          </a:p>
+        </p:txBody>
+      </p:sp>
+      <p:sp>
+        <p:nvSpPr>
+          <p:cNvPr id="4" name="Espaço Reservado para Texto 3">
+            <a:extLst>
+              <a:ext uri="{FF2B5EF4-FFF2-40B4-BE49-F238E27FC236}">
+                <a16:creationId xmlns:a16="http://schemas.microsoft.com/office/drawing/2014/main" id="{714E09CF-7753-AF82-DFE1-03BE51F74ECE}"/>
+              </a:ext>
+            </a:extLst>
+          </p:cNvPr>
           <p:cNvSpPr>
             <a:spLocks noGrp="1"/>
           </p:cNvSpPr>
@@ -2439,8 +2589,8 @@
         </p:nvSpPr>
         <p:spPr>
           <a:xfrm>
-            <a:off x="1792288" y="5367338"/>
-            <a:ext cx="5486400" cy="804862"/>
+            <a:off x="839788" y="2057400"/>
+            <a:ext cx="3932237" cy="3811588"/>
           </a:xfrm>
         </p:spPr>
         <p:txBody>
@@ -2448,53 +2598,59 @@
           <a:lstStyle>
             <a:lvl1pPr marL="0" indent="0">
               <a:buNone/>
-              <a:defRPr sz="1400"/>
+              <a:defRPr sz="1600"/>
             </a:lvl1pPr>
             <a:lvl2pPr marL="457200" indent="0">
               <a:buNone/>
-              <a:defRPr sz="1200"/>
+              <a:defRPr sz="1400"/>
             </a:lvl2pPr>
             <a:lvl3pPr marL="914400" indent="0">
               <a:buNone/>
-              <a:defRPr sz="1000"/>
+              <a:defRPr sz="1200"/>
             </a:lvl3pPr>
             <a:lvl4pPr marL="1371600" indent="0">
               <a:buNone/>
-              <a:defRPr sz="900"/>
+              <a:defRPr sz="1000"/>
             </a:lvl4pPr>
             <a:lvl5pPr marL="1828800" indent="0">
               <a:buNone/>
-              <a:defRPr sz="900"/>
+              <a:defRPr sz="1000"/>
             </a:lvl5pPr>
             <a:lvl6pPr marL="2286000" indent="0">
               <a:buNone/>
-              <a:defRPr sz="900"/>
+              <a:defRPr sz="1000"/>
             </a:lvl6pPr>
             <a:lvl7pPr marL="2743200" indent="0">
               <a:buNone/>
-              <a:defRPr sz="900"/>
+              <a:defRPr sz="1000"/>
             </a:lvl7pPr>
             <a:lvl8pPr marL="3200400" indent="0">
               <a:buNone/>
-              <a:defRPr sz="900"/>
+              <a:defRPr sz="1000"/>
             </a:lvl8pPr>
             <a:lvl9pPr marL="3657600" indent="0">
               <a:buNone/>
-              <a:defRPr sz="900"/>
+              <a:defRPr sz="1000"/>
             </a:lvl9pPr>
           </a:lstStyle>
           <a:p>
             <a:pPr lvl="0"/>
             <a:r>
-              <a:rPr lang="en-US" smtClean="0"/>
-              <a:t>Click to edit Master text styles</a:t>
-            </a:r>
-          </a:p>
-        </p:txBody>
-      </p:sp>
-      <p:sp>
-        <p:nvSpPr>
-          <p:cNvPr id="5" name="Date Placeholder 4"/>
+              <a:rPr lang="pt-BR"/>
+              <a:t>Clique para editar os estilos de texto Mestres</a:t>
+            </a:r>
+          </a:p>
+        </p:txBody>
+      </p:sp>
+      <p:sp>
+        <p:nvSpPr>
+          <p:cNvPr id="5" name="Espaço Reservado para Data 4">
+            <a:extLst>
+              <a:ext uri="{FF2B5EF4-FFF2-40B4-BE49-F238E27FC236}">
+                <a16:creationId xmlns:a16="http://schemas.microsoft.com/office/drawing/2014/main" id="{1EE84F10-9DBF-1DDF-91C2-0FCC8CC5D7E1}"/>
+              </a:ext>
+            </a:extLst>
+          </p:cNvPr>
           <p:cNvSpPr>
             <a:spLocks noGrp="1"/>
           </p:cNvSpPr>
@@ -2507,17 +2663,23 @@
           <a:bodyPr/>
           <a:lstStyle/>
           <a:p>
-            <a:fld id="{5BCAD085-E8A6-8845-BD4E-CB4CCA059FC4}" type="datetimeFigureOut">
-              <a:rPr lang="en-US" smtClean="0"/>
-              <a:t>1/27/13</a:t>
+            <a:fld id="{22C9067A-926A-4F91-B7AE-7AC6F651DD3F}" type="datetimeFigureOut">
+              <a:rPr lang="pt-BR" smtClean="0"/>
+              <a:t>06/07/2026</a:t>
             </a:fld>
-            <a:endParaRPr lang="en-US"/>
-          </a:p>
-        </p:txBody>
-      </p:sp>
-      <p:sp>
-        <p:nvSpPr>
-          <p:cNvPr id="6" name="Footer Placeholder 5"/>
+            <a:endParaRPr lang="pt-BR"/>
+          </a:p>
+        </p:txBody>
+      </p:sp>
+      <p:sp>
+        <p:nvSpPr>
+          <p:cNvPr id="6" name="Espaço Reservado para Rodapé 5">
+            <a:extLst>
+              <a:ext uri="{FF2B5EF4-FFF2-40B4-BE49-F238E27FC236}">
+                <a16:creationId xmlns:a16="http://schemas.microsoft.com/office/drawing/2014/main" id="{D2A25F6F-A14B-07C3-793A-F1F1C6190370}"/>
+              </a:ext>
+            </a:extLst>
+          </p:cNvPr>
           <p:cNvSpPr>
             <a:spLocks noGrp="1"/>
           </p:cNvSpPr>
@@ -2530,13 +2692,19 @@
           <a:bodyPr/>
           <a:lstStyle/>
           <a:p>
-            <a:endParaRPr lang="en-US"/>
-          </a:p>
-        </p:txBody>
-      </p:sp>
-      <p:sp>
-        <p:nvSpPr>
-          <p:cNvPr id="7" name="Slide Number Placeholder 6"/>
+            <a:endParaRPr lang="pt-BR"/>
+          </a:p>
+        </p:txBody>
+      </p:sp>
+      <p:sp>
+        <p:nvSpPr>
+          <p:cNvPr id="7" name="Espaço Reservado para Número de Slide 6">
+            <a:extLst>
+              <a:ext uri="{FF2B5EF4-FFF2-40B4-BE49-F238E27FC236}">
+                <a16:creationId xmlns:a16="http://schemas.microsoft.com/office/drawing/2014/main" id="{7280308C-3CDB-98FB-E421-1E0C3320CF64}"/>
+              </a:ext>
+            </a:extLst>
+          </p:cNvPr>
           <p:cNvSpPr>
             <a:spLocks noGrp="1"/>
           </p:cNvSpPr>
@@ -2549,18 +2717,18 @@
           <a:bodyPr/>
           <a:lstStyle/>
           <a:p>
-            <a:fld id="{C1FF6DA9-008F-8B48-92A6-B652298478BF}" type="slidenum">
-              <a:rPr lang="en-US" smtClean="0"/>
-              <a:t>‹#›</a:t>
+            <a:fld id="{04F480B6-C421-4DC2-BA7E-81BCB3D20179}" type="slidenum">
+              <a:rPr lang="pt-BR" smtClean="0"/>
+              <a:t>‹nº›</a:t>
             </a:fld>
-            <a:endParaRPr lang="en-US"/>
+            <a:endParaRPr lang="pt-BR"/>
           </a:p>
         </p:txBody>
       </p:sp>
     </p:spTree>
     <p:extLst>
       <p:ext uri="{BB962C8B-B14F-4D97-AF65-F5344CB8AC3E}">
-        <p14:creationId xmlns:p14="http://schemas.microsoft.com/office/powerpoint/2010/main" val="3889236939"/>
+        <p14:creationId xmlns:p14="http://schemas.microsoft.com/office/powerpoint/2010/main" val="2898534828"/>
       </p:ext>
     </p:extLst>
   </p:cSld>
@@ -2594,7 +2762,13 @@
       </p:grpSpPr>
       <p:sp>
         <p:nvSpPr>
-          <p:cNvPr id="2" name="Title Placeholder 1"/>
+          <p:cNvPr id="2" name="Espaço Reservado para Título 1">
+            <a:extLst>
+              <a:ext uri="{FF2B5EF4-FFF2-40B4-BE49-F238E27FC236}">
+                <a16:creationId xmlns:a16="http://schemas.microsoft.com/office/drawing/2014/main" id="{9200EF5A-2D96-2F10-849B-2D57DD53A162}"/>
+              </a:ext>
+            </a:extLst>
+          </p:cNvPr>
           <p:cNvSpPr>
             <a:spLocks noGrp="1"/>
           </p:cNvSpPr>
@@ -2604,8 +2778,8 @@
         </p:nvSpPr>
         <p:spPr>
           <a:xfrm>
-            <a:off x="457200" y="274638"/>
-            <a:ext cx="8229600" cy="1143000"/>
+            <a:off x="838200" y="365125"/>
+            <a:ext cx="10515600" cy="1325563"/>
           </a:xfrm>
           <a:prstGeom prst="rect">
             <a:avLst/>
@@ -2618,16 +2792,21 @@
           <a:lstStyle/>
           <a:p>
             <a:r>
-              <a:rPr lang="en-US" smtClean="0"/>
-              <a:t>Click to edit Master title style</a:t>
-            </a:r>
-            <a:endParaRPr lang="en-US"/>
-          </a:p>
-        </p:txBody>
-      </p:sp>
-      <p:sp>
-        <p:nvSpPr>
-          <p:cNvPr id="3" name="Text Placeholder 2"/>
+              <a:rPr lang="pt-BR"/>
+              <a:t>Clique para editar o título Mestre</a:t>
+            </a:r>
+          </a:p>
+        </p:txBody>
+      </p:sp>
+      <p:sp>
+        <p:nvSpPr>
+          <p:cNvPr id="3" name="Espaço Reservado para Texto 2">
+            <a:extLst>
+              <a:ext uri="{FF2B5EF4-FFF2-40B4-BE49-F238E27FC236}">
+                <a16:creationId xmlns:a16="http://schemas.microsoft.com/office/drawing/2014/main" id="{CC366606-5C23-B6D6-B860-4FE523ED9C97}"/>
+              </a:ext>
+            </a:extLst>
+          </p:cNvPr>
           <p:cNvSpPr>
             <a:spLocks noGrp="1"/>
           </p:cNvSpPr>
@@ -2637,8 +2816,8 @@
         </p:nvSpPr>
         <p:spPr>
           <a:xfrm>
-            <a:off x="457200" y="1600200"/>
-            <a:ext cx="8229600" cy="4525963"/>
+            <a:off x="838200" y="1825625"/>
+            <a:ext cx="10515600" cy="4351338"/>
           </a:xfrm>
           <a:prstGeom prst="rect">
             <a:avLst/>
@@ -2652,44 +2831,49 @@
           <a:p>
             <a:pPr lvl="0"/>
             <a:r>
-              <a:rPr lang="en-US" smtClean="0"/>
-              <a:t>Click to edit Master text styles</a:t>
+              <a:rPr lang="pt-BR"/>
+              <a:t>Clique para editar os estilos de texto Mestres</a:t>
             </a:r>
           </a:p>
           <a:p>
             <a:pPr lvl="1"/>
             <a:r>
-              <a:rPr lang="en-US" smtClean="0"/>
-              <a:t>Second level</a:t>
+              <a:rPr lang="pt-BR"/>
+              <a:t>Segundo nível</a:t>
             </a:r>
           </a:p>
           <a:p>
             <a:pPr lvl="2"/>
             <a:r>
-              <a:rPr lang="en-US" smtClean="0"/>
-              <a:t>Third level</a:t>
+              <a:rPr lang="pt-BR"/>
+              <a:t>Terceiro nível</a:t>
             </a:r>
           </a:p>
           <a:p>
             <a:pPr lvl="3"/>
             <a:r>
-              <a:rPr lang="en-US" smtClean="0"/>
-              <a:t>Fourth level</a:t>
+              <a:rPr lang="pt-BR"/>
+              <a:t>Quarto nível</a:t>
             </a:r>
           </a:p>
           <a:p>
             <a:pPr lvl="4"/>
             <a:r>
-              <a:rPr lang="en-US" smtClean="0"/>
-              <a:t>Fifth level</a:t>
-            </a:r>
-            <a:endParaRPr lang="en-US"/>
-          </a:p>
-        </p:txBody>
-      </p:sp>
-      <p:sp>
-        <p:nvSpPr>
-          <p:cNvPr id="4" name="Date Placeholder 3"/>
+              <a:rPr lang="pt-BR"/>
+              <a:t>Quinto nível</a:t>
+            </a:r>
+          </a:p>
+        </p:txBody>
+      </p:sp>
+      <p:sp>
+        <p:nvSpPr>
+          <p:cNvPr id="4" name="Espaço Reservado para Data 3">
+            <a:extLst>
+              <a:ext uri="{FF2B5EF4-FFF2-40B4-BE49-F238E27FC236}">
+                <a16:creationId xmlns:a16="http://schemas.microsoft.com/office/drawing/2014/main" id="{7DC8D624-4CD0-44EC-FCF8-805F529037DE}"/>
+              </a:ext>
+            </a:extLst>
+          </p:cNvPr>
           <p:cNvSpPr>
             <a:spLocks noGrp="1"/>
           </p:cNvSpPr>
@@ -2699,8 +2883,8 @@
         </p:nvSpPr>
         <p:spPr>
           <a:xfrm>
-            <a:off x="457200" y="6356350"/>
-            <a:ext cx="2133600" cy="365125"/>
+            <a:off x="838200" y="6356350"/>
+            <a:ext cx="2743200" cy="365125"/>
           </a:xfrm>
           <a:prstGeom prst="rect">
             <a:avLst/>
@@ -2713,24 +2897,30 @@
               <a:defRPr sz="1200">
                 <a:solidFill>
                   <a:schemeClr val="tx1">
-                    <a:tint val="75000"/>
+                    <a:tint val="82000"/>
                   </a:schemeClr>
                 </a:solidFill>
               </a:defRPr>
             </a:lvl1pPr>
           </a:lstStyle>
           <a:p>
-            <a:fld id="{5BCAD085-E8A6-8845-BD4E-CB4CCA059FC4}" type="datetimeFigureOut">
-              <a:rPr lang="en-US" smtClean="0"/>
-              <a:t>1/27/13</a:t>
+            <a:fld id="{22C9067A-926A-4F91-B7AE-7AC6F651DD3F}" type="datetimeFigureOut">
+              <a:rPr lang="pt-BR" smtClean="0"/>
+              <a:t>06/07/2026</a:t>
             </a:fld>
-            <a:endParaRPr lang="en-US"/>
-          </a:p>
-        </p:txBody>
-      </p:sp>
-      <p:sp>
-        <p:nvSpPr>
-          <p:cNvPr id="5" name="Footer Placeholder 4"/>
+            <a:endParaRPr lang="pt-BR"/>
+          </a:p>
+        </p:txBody>
+      </p:sp>
+      <p:sp>
+        <p:nvSpPr>
+          <p:cNvPr id="5" name="Espaço Reservado para Rodapé 4">
+            <a:extLst>
+              <a:ext uri="{FF2B5EF4-FFF2-40B4-BE49-F238E27FC236}">
+                <a16:creationId xmlns:a16="http://schemas.microsoft.com/office/drawing/2014/main" id="{4E77E924-3319-19DC-C272-803FEC6C0159}"/>
+              </a:ext>
+            </a:extLst>
+          </p:cNvPr>
           <p:cNvSpPr>
             <a:spLocks noGrp="1"/>
           </p:cNvSpPr>
@@ -2740,8 +2930,8 @@
         </p:nvSpPr>
         <p:spPr>
           <a:xfrm>
-            <a:off x="3124200" y="6356350"/>
-            <a:ext cx="2895600" cy="365125"/>
+            <a:off x="4038600" y="6356350"/>
+            <a:ext cx="4114800" cy="365125"/>
           </a:xfrm>
           <a:prstGeom prst="rect">
             <a:avLst/>
@@ -2754,20 +2944,26 @@
               <a:defRPr sz="1200">
                 <a:solidFill>
                   <a:schemeClr val="tx1">
-                    <a:tint val="75000"/>
+                    <a:tint val="82000"/>
                   </a:schemeClr>
                 </a:solidFill>
               </a:defRPr>
             </a:lvl1pPr>
           </a:lstStyle>
           <a:p>
-            <a:endParaRPr lang="en-US"/>
-          </a:p>
-        </p:txBody>
-      </p:sp>
-      <p:sp>
-        <p:nvSpPr>
-          <p:cNvPr id="6" name="Slide Number Placeholder 5"/>
+            <a:endParaRPr lang="pt-BR"/>
+          </a:p>
+        </p:txBody>
+      </p:sp>
+      <p:sp>
+        <p:nvSpPr>
+          <p:cNvPr id="6" name="Espaço Reservado para Número de Slide 5">
+            <a:extLst>
+              <a:ext uri="{FF2B5EF4-FFF2-40B4-BE49-F238E27FC236}">
+                <a16:creationId xmlns:a16="http://schemas.microsoft.com/office/drawing/2014/main" id="{3BFD9EC9-64E4-3080-6E32-EB950482D0F0}"/>
+              </a:ext>
+            </a:extLst>
+          </p:cNvPr>
           <p:cNvSpPr>
             <a:spLocks noGrp="1"/>
           </p:cNvSpPr>
@@ -2777,8 +2973,8 @@
         </p:nvSpPr>
         <p:spPr>
           <a:xfrm>
-            <a:off x="6553200" y="6356350"/>
-            <a:ext cx="2133600" cy="365125"/>
+            <a:off x="8610600" y="6356350"/>
+            <a:ext cx="2743200" cy="365125"/>
           </a:xfrm>
           <a:prstGeom prst="rect">
             <a:avLst/>
@@ -2791,25 +2987,25 @@
               <a:defRPr sz="1200">
                 <a:solidFill>
                   <a:schemeClr val="tx1">
-                    <a:tint val="75000"/>
+                    <a:tint val="82000"/>
                   </a:schemeClr>
                 </a:solidFill>
               </a:defRPr>
             </a:lvl1pPr>
           </a:lstStyle>
           <a:p>
-            <a:fld id="{C1FF6DA9-008F-8B48-92A6-B652298478BF}" type="slidenum">
-              <a:rPr lang="en-US" smtClean="0"/>
-              <a:t>‹#›</a:t>
+            <a:fld id="{04F480B6-C421-4DC2-BA7E-81BCB3D20179}" type="slidenum">
+              <a:rPr lang="pt-BR" smtClean="0"/>
+              <a:t>‹nº›</a:t>
             </a:fld>
-            <a:endParaRPr lang="en-US"/>
+            <a:endParaRPr lang="pt-BR"/>
           </a:p>
         </p:txBody>
       </p:sp>
     </p:spTree>
     <p:extLst>
       <p:ext uri="{BB962C8B-B14F-4D97-AF65-F5344CB8AC3E}">
-        <p14:creationId xmlns:p14="http://schemas.microsoft.com/office/powerpoint/2010/main" val="2209977519"/>
+        <p14:creationId xmlns:p14="http://schemas.microsoft.com/office/powerpoint/2010/main" val="4061729181"/>
       </p:ext>
     </p:extLst>
   </p:cSld>
@@ -2829,7 +3025,10 @@
   </p:sldLayoutIdLst>
   <p:txStyles>
     <p:titleStyle>
-      <a:lvl1pPr algn="ctr" defTabSz="457200" rtl="0" eaLnBrk="1" latinLnBrk="0" hangingPunct="1">
+      <a:lvl1pPr algn="l" defTabSz="914400" rtl="0" eaLnBrk="1" latinLnBrk="0" hangingPunct="1">
+        <a:lnSpc>
+          <a:spcPct val="90000"/>
+        </a:lnSpc>
         <a:spcBef>
           <a:spcPct val="0"/>
         </a:spcBef>
@@ -2845,13 +3044,16 @@
       </a:lvl1pPr>
     </p:titleStyle>
     <p:bodyStyle>
-      <a:lvl1pPr marL="342900" indent="-342900" algn="l" defTabSz="457200" rtl="0" eaLnBrk="1" latinLnBrk="0" hangingPunct="1">
+      <a:lvl1pPr marL="228600" indent="-228600" algn="l" defTabSz="914400" rtl="0" eaLnBrk="1" latinLnBrk="0" hangingPunct="1">
+        <a:lnSpc>
+          <a:spcPct val="90000"/>
+        </a:lnSpc>
         <a:spcBef>
-          <a:spcPct val="20000"/>
+          <a:spcPts val="1000"/>
         </a:spcBef>
-        <a:buFont typeface="Arial"/>
+        <a:buFont typeface="Arial" panose="020B0604020202020204" pitchFamily="34" charset="0"/>
         <a:buChar char="•"/>
-        <a:defRPr sz="3200" kern="1200">
+        <a:defRPr sz="2800" kern="1200">
           <a:solidFill>
             <a:schemeClr val="tx1"/>
           </a:solidFill>
@@ -2860,26 +3062,14 @@
           <a:cs typeface="+mn-cs"/>
         </a:defRPr>
       </a:lvl1pPr>
-      <a:lvl2pPr marL="742950" indent="-285750" algn="l" defTabSz="457200" rtl="0" eaLnBrk="1" latinLnBrk="0" hangingPunct="1">
+      <a:lvl2pPr marL="685800" indent="-228600" algn="l" defTabSz="914400" rtl="0" eaLnBrk="1" latinLnBrk="0" hangingPunct="1">
+        <a:lnSpc>
+          <a:spcPct val="90000"/>
+        </a:lnSpc>
         <a:spcBef>
-          <a:spcPct val="20000"/>
+          <a:spcPts val="500"/>
         </a:spcBef>
-        <a:buFont typeface="Arial"/>
-        <a:buChar char="–"/>
-        <a:defRPr sz="2800" kern="1200">
-          <a:solidFill>
-            <a:schemeClr val="tx1"/>
-          </a:solidFill>
-          <a:latin typeface="+mn-lt"/>
-          <a:ea typeface="+mn-ea"/>
-          <a:cs typeface="+mn-cs"/>
-        </a:defRPr>
-      </a:lvl2pPr>
-      <a:lvl3pPr marL="1143000" indent="-228600" algn="l" defTabSz="457200" rtl="0" eaLnBrk="1" latinLnBrk="0" hangingPunct="1">
-        <a:spcBef>
-          <a:spcPct val="20000"/>
-        </a:spcBef>
-        <a:buFont typeface="Arial"/>
+        <a:buFont typeface="Arial" panose="020B0604020202020204" pitchFamily="34" charset="0"/>
         <a:buChar char="•"/>
         <a:defRPr sz="2400" kern="1200">
           <a:solidFill>
@@ -2889,42 +3079,15 @@
           <a:ea typeface="+mn-ea"/>
           <a:cs typeface="+mn-cs"/>
         </a:defRPr>
-      </a:lvl3pPr>
-      <a:lvl4pPr marL="1600200" indent="-228600" algn="l" defTabSz="457200" rtl="0" eaLnBrk="1" latinLnBrk="0" hangingPunct="1">
+      </a:lvl2pPr>
+      <a:lvl3pPr marL="1143000" indent="-228600" algn="l" defTabSz="914400" rtl="0" eaLnBrk="1" latinLnBrk="0" hangingPunct="1">
+        <a:lnSpc>
+          <a:spcPct val="90000"/>
+        </a:lnSpc>
         <a:spcBef>
-          <a:spcPct val="20000"/>
+          <a:spcPts val="500"/>
         </a:spcBef>
-        <a:buFont typeface="Arial"/>
-        <a:buChar char="–"/>
-        <a:defRPr sz="2000" kern="1200">
-          <a:solidFill>
-            <a:schemeClr val="tx1"/>
-          </a:solidFill>
-          <a:latin typeface="+mn-lt"/>
-          <a:ea typeface="+mn-ea"/>
-          <a:cs typeface="+mn-cs"/>
-        </a:defRPr>
-      </a:lvl4pPr>
-      <a:lvl5pPr marL="2057400" indent="-228600" algn="l" defTabSz="457200" rtl="0" eaLnBrk="1" latinLnBrk="0" hangingPunct="1">
-        <a:spcBef>
-          <a:spcPct val="20000"/>
-        </a:spcBef>
-        <a:buFont typeface="Arial"/>
-        <a:buChar char="»"/>
-        <a:defRPr sz="2000" kern="1200">
-          <a:solidFill>
-            <a:schemeClr val="tx1"/>
-          </a:solidFill>
-          <a:latin typeface="+mn-lt"/>
-          <a:ea typeface="+mn-ea"/>
-          <a:cs typeface="+mn-cs"/>
-        </a:defRPr>
-      </a:lvl5pPr>
-      <a:lvl6pPr marL="2514600" indent="-228600" algn="l" defTabSz="457200" rtl="0" eaLnBrk="1" latinLnBrk="0" hangingPunct="1">
-        <a:spcBef>
-          <a:spcPct val="20000"/>
-        </a:spcBef>
-        <a:buFont typeface="Arial"/>
+        <a:buFont typeface="Arial" panose="020B0604020202020204" pitchFamily="34" charset="0"/>
         <a:buChar char="•"/>
         <a:defRPr sz="2000" kern="1200">
           <a:solidFill>
@@ -2934,14 +3097,71 @@
           <a:ea typeface="+mn-ea"/>
           <a:cs typeface="+mn-cs"/>
         </a:defRPr>
+      </a:lvl3pPr>
+      <a:lvl4pPr marL="1600200" indent="-228600" algn="l" defTabSz="914400" rtl="0" eaLnBrk="1" latinLnBrk="0" hangingPunct="1">
+        <a:lnSpc>
+          <a:spcPct val="90000"/>
+        </a:lnSpc>
+        <a:spcBef>
+          <a:spcPts val="500"/>
+        </a:spcBef>
+        <a:buFont typeface="Arial" panose="020B0604020202020204" pitchFamily="34" charset="0"/>
+        <a:buChar char="•"/>
+        <a:defRPr sz="1800" kern="1200">
+          <a:solidFill>
+            <a:schemeClr val="tx1"/>
+          </a:solidFill>
+          <a:latin typeface="+mn-lt"/>
+          <a:ea typeface="+mn-ea"/>
+          <a:cs typeface="+mn-cs"/>
+        </a:defRPr>
+      </a:lvl4pPr>
+      <a:lvl5pPr marL="2057400" indent="-228600" algn="l" defTabSz="914400" rtl="0" eaLnBrk="1" latinLnBrk="0" hangingPunct="1">
+        <a:lnSpc>
+          <a:spcPct val="90000"/>
+        </a:lnSpc>
+        <a:spcBef>
+          <a:spcPts val="500"/>
+        </a:spcBef>
+        <a:buFont typeface="Arial" panose="020B0604020202020204" pitchFamily="34" charset="0"/>
+        <a:buChar char="•"/>
+        <a:defRPr sz="1800" kern="1200">
+          <a:solidFill>
+            <a:schemeClr val="tx1"/>
+          </a:solidFill>
+          <a:latin typeface="+mn-lt"/>
+          <a:ea typeface="+mn-ea"/>
+          <a:cs typeface="+mn-cs"/>
+        </a:defRPr>
+      </a:lvl5pPr>
+      <a:lvl6pPr marL="2514600" indent="-228600" algn="l" defTabSz="914400" rtl="0" eaLnBrk="1" latinLnBrk="0" hangingPunct="1">
+        <a:lnSpc>
+          <a:spcPct val="90000"/>
+        </a:lnSpc>
+        <a:spcBef>
+          <a:spcPts val="500"/>
+        </a:spcBef>
+        <a:buFont typeface="Arial" panose="020B0604020202020204" pitchFamily="34" charset="0"/>
+        <a:buChar char="•"/>
+        <a:defRPr sz="1800" kern="1200">
+          <a:solidFill>
+            <a:schemeClr val="tx1"/>
+          </a:solidFill>
+          <a:latin typeface="+mn-lt"/>
+          <a:ea typeface="+mn-ea"/>
+          <a:cs typeface="+mn-cs"/>
+        </a:defRPr>
       </a:lvl6pPr>
-      <a:lvl7pPr marL="2971800" indent="-228600" algn="l" defTabSz="457200" rtl="0" eaLnBrk="1" latinLnBrk="0" hangingPunct="1">
+      <a:lvl7pPr marL="2971800" indent="-228600" algn="l" defTabSz="914400" rtl="0" eaLnBrk="1" latinLnBrk="0" hangingPunct="1">
+        <a:lnSpc>
+          <a:spcPct val="90000"/>
+        </a:lnSpc>
         <a:spcBef>
-          <a:spcPct val="20000"/>
+          <a:spcPts val="500"/>
         </a:spcBef>
-        <a:buFont typeface="Arial"/>
+        <a:buFont typeface="Arial" panose="020B0604020202020204" pitchFamily="34" charset="0"/>
         <a:buChar char="•"/>
-        <a:defRPr sz="2000" kern="1200">
+        <a:defRPr sz="1800" kern="1200">
           <a:solidFill>
             <a:schemeClr val="tx1"/>
           </a:solidFill>
@@ -2950,13 +3170,16 @@
           <a:cs typeface="+mn-cs"/>
         </a:defRPr>
       </a:lvl7pPr>
-      <a:lvl8pPr marL="3429000" indent="-228600" algn="l" defTabSz="457200" rtl="0" eaLnBrk="1" latinLnBrk="0" hangingPunct="1">
+      <a:lvl8pPr marL="3429000" indent="-228600" algn="l" defTabSz="914400" rtl="0" eaLnBrk="1" latinLnBrk="0" hangingPunct="1">
+        <a:lnSpc>
+          <a:spcPct val="90000"/>
+        </a:lnSpc>
         <a:spcBef>
-          <a:spcPct val="20000"/>
+          <a:spcPts val="500"/>
         </a:spcBef>
-        <a:buFont typeface="Arial"/>
+        <a:buFont typeface="Arial" panose="020B0604020202020204" pitchFamily="34" charset="0"/>
         <a:buChar char="•"/>
-        <a:defRPr sz="2000" kern="1200">
+        <a:defRPr sz="1800" kern="1200">
           <a:solidFill>
             <a:schemeClr val="tx1"/>
           </a:solidFill>
@@ -2965,13 +3188,16 @@
           <a:cs typeface="+mn-cs"/>
         </a:defRPr>
       </a:lvl8pPr>
-      <a:lvl9pPr marL="3886200" indent="-228600" algn="l" defTabSz="457200" rtl="0" eaLnBrk="1" latinLnBrk="0" hangingPunct="1">
+      <a:lvl9pPr marL="3886200" indent="-228600" algn="l" defTabSz="914400" rtl="0" eaLnBrk="1" latinLnBrk="0" hangingPunct="1">
+        <a:lnSpc>
+          <a:spcPct val="90000"/>
+        </a:lnSpc>
         <a:spcBef>
-          <a:spcPct val="20000"/>
+          <a:spcPts val="500"/>
         </a:spcBef>
-        <a:buFont typeface="Arial"/>
+        <a:buFont typeface="Arial" panose="020B0604020202020204" pitchFamily="34" charset="0"/>
         <a:buChar char="•"/>
-        <a:defRPr sz="2000" kern="1200">
+        <a:defRPr sz="1800" kern="1200">
           <a:solidFill>
             <a:schemeClr val="tx1"/>
           </a:solidFill>
@@ -2983,9 +3209,9 @@
     </p:bodyStyle>
     <p:otherStyle>
       <a:defPPr>
-        <a:defRPr lang="en-US"/>
+        <a:defRPr lang="pt-BR"/>
       </a:defPPr>
-      <a:lvl1pPr marL="0" algn="l" defTabSz="457200" rtl="0" eaLnBrk="1" latinLnBrk="0" hangingPunct="1">
+      <a:lvl1pPr marL="0" algn="l" defTabSz="914400" rtl="0" eaLnBrk="1" latinLnBrk="0" hangingPunct="1">
         <a:defRPr sz="1800" kern="1200">
           <a:solidFill>
             <a:schemeClr val="tx1"/>
@@ -2995,7 +3221,7 @@
           <a:cs typeface="+mn-cs"/>
         </a:defRPr>
       </a:lvl1pPr>
-      <a:lvl2pPr marL="457200" algn="l" defTabSz="457200" rtl="0" eaLnBrk="1" latinLnBrk="0" hangingPunct="1">
+      <a:lvl2pPr marL="457200" algn="l" defTabSz="914400" rtl="0" eaLnBrk="1" latinLnBrk="0" hangingPunct="1">
         <a:defRPr sz="1800" kern="1200">
           <a:solidFill>
             <a:schemeClr val="tx1"/>
@@ -3005,7 +3231,7 @@
           <a:cs typeface="+mn-cs"/>
         </a:defRPr>
       </a:lvl2pPr>
-      <a:lvl3pPr marL="914400" algn="l" defTabSz="457200" rtl="0" eaLnBrk="1" latinLnBrk="0" hangingPunct="1">
+      <a:lvl3pPr marL="914400" algn="l" defTabSz="914400" rtl="0" eaLnBrk="1" latinLnBrk="0" hangingPunct="1">
         <a:defRPr sz="1800" kern="1200">
           <a:solidFill>
             <a:schemeClr val="tx1"/>
@@ -3015,7 +3241,7 @@
           <a:cs typeface="+mn-cs"/>
         </a:defRPr>
       </a:lvl3pPr>
-      <a:lvl4pPr marL="1371600" algn="l" defTabSz="457200" rtl="0" eaLnBrk="1" latinLnBrk="0" hangingPunct="1">
+      <a:lvl4pPr marL="1371600" algn="l" defTabSz="914400" rtl="0" eaLnBrk="1" latinLnBrk="0" hangingPunct="1">
         <a:defRPr sz="1800" kern="1200">
           <a:solidFill>
             <a:schemeClr val="tx1"/>
@@ -3025,7 +3251,7 @@
           <a:cs typeface="+mn-cs"/>
         </a:defRPr>
       </a:lvl4pPr>
-      <a:lvl5pPr marL="1828800" algn="l" defTabSz="457200" rtl="0" eaLnBrk="1" latinLnBrk="0" hangingPunct="1">
+      <a:lvl5pPr marL="1828800" algn="l" defTabSz="914400" rtl="0" eaLnBrk="1" latinLnBrk="0" hangingPunct="1">
         <a:defRPr sz="1800" kern="1200">
           <a:solidFill>
             <a:schemeClr val="tx1"/>
@@ -3035,7 +3261,7 @@
           <a:cs typeface="+mn-cs"/>
         </a:defRPr>
       </a:lvl5pPr>
-      <a:lvl6pPr marL="2286000" algn="l" defTabSz="457200" rtl="0" eaLnBrk="1" latinLnBrk="0" hangingPunct="1">
+      <a:lvl6pPr marL="2286000" algn="l" defTabSz="914400" rtl="0" eaLnBrk="1" latinLnBrk="0" hangingPunct="1">
         <a:defRPr sz="1800" kern="1200">
           <a:solidFill>
             <a:schemeClr val="tx1"/>
@@ -3045,7 +3271,7 @@
           <a:cs typeface="+mn-cs"/>
         </a:defRPr>
       </a:lvl6pPr>
-      <a:lvl7pPr marL="2743200" algn="l" defTabSz="457200" rtl="0" eaLnBrk="1" latinLnBrk="0" hangingPunct="1">
+      <a:lvl7pPr marL="2743200" algn="l" defTabSz="914400" rtl="0" eaLnBrk="1" latinLnBrk="0" hangingPunct="1">
         <a:defRPr sz="1800" kern="1200">
           <a:solidFill>
             <a:schemeClr val="tx1"/>
@@ -3055,7 +3281,7 @@
           <a:cs typeface="+mn-cs"/>
         </a:defRPr>
       </a:lvl7pPr>
-      <a:lvl8pPr marL="3200400" algn="l" defTabSz="457200" rtl="0" eaLnBrk="1" latinLnBrk="0" hangingPunct="1">
+      <a:lvl8pPr marL="3200400" algn="l" defTabSz="914400" rtl="0" eaLnBrk="1" latinLnBrk="0" hangingPunct="1">
         <a:defRPr sz="1800" kern="1200">
           <a:solidFill>
             <a:schemeClr val="tx1"/>
@@ -3065,7 +3291,7 @@
           <a:cs typeface="+mn-cs"/>
         </a:defRPr>
       </a:lvl8pPr>
-      <a:lvl9pPr marL="3657600" algn="l" defTabSz="457200" rtl="0" eaLnBrk="1" latinLnBrk="0" hangingPunct="1">
+      <a:lvl9pPr marL="3657600" algn="l" defTabSz="914400" rtl="0" eaLnBrk="1" latinLnBrk="0" hangingPunct="1">
         <a:defRPr sz="1800" kern="1200">
           <a:solidFill>
             <a:schemeClr val="tx1"/>
@@ -3081,7 +3307,7 @@
 </file>
 
 <file path=ppt/slides/slide1.xml><?xml version="1.0" encoding="utf-8"?>
-<p:sld xmlns:a="http://schemas.openxmlformats.org/drawingml/2006/main" xmlns:p="http://schemas.openxmlformats.org/presentationml/2006/main" xmlns:r="http://schemas.openxmlformats.org/officeDocument/2006/relationships">
+<p:sld xmlns:a="http://schemas.openxmlformats.org/drawingml/2006/main" xmlns:r="http://schemas.openxmlformats.org/officeDocument/2006/relationships" xmlns:p="http://schemas.openxmlformats.org/presentationml/2006/main">
   <p:cSld>
     <p:spTree>
       <p:nvGrpSpPr>
@@ -3089,10 +3315,23 @@
         <p:cNvGrpSpPr/>
         <p:nvPr/>
       </p:nvGrpSpPr>
-      <p:grpSpPr/>
+      <p:grpSpPr>
+        <a:xfrm>
+          <a:off x="0" y="0"/>
+          <a:ext cx="0" cy="0"/>
+          <a:chOff x="0" y="0"/>
+          <a:chExt cx="0" cy="0"/>
+        </a:xfrm>
+      </p:grpSpPr>
       <p:pic>
         <p:nvPicPr>
-          <p:cNvPr id="2" name="Picture 1" descr="image.png"/>
+          <p:cNvPr id="5" name="Imagem 4">
+            <a:extLst>
+              <a:ext uri="{FF2B5EF4-FFF2-40B4-BE49-F238E27FC236}">
+                <a16:creationId xmlns:a16="http://schemas.microsoft.com/office/drawing/2014/main" id="{5A7EF94A-643B-9FE2-F08B-CB0F60512EAD}"/>
+              </a:ext>
+            </a:extLst>
+          </p:cNvPr>
           <p:cNvPicPr>
             <a:picLocks noChangeAspect="1"/>
           </p:cNvPicPr>
@@ -3106,8 +3345,8 @@
         </p:blipFill>
         <p:spPr>
           <a:xfrm>
-            <a:off x="0" y="0"/>
-            <a:ext cx="9144000" cy="6858000"/>
+            <a:off x="0" y="544884"/>
+            <a:ext cx="12192000" cy="5514736"/>
           </a:xfrm>
           <a:prstGeom prst="rect">
             <a:avLst/>
@@ -3115,6 +3354,11 @@
         </p:spPr>
       </p:pic>
     </p:spTree>
+    <p:extLst>
+      <p:ext uri="{BB962C8B-B14F-4D97-AF65-F5344CB8AC3E}">
+        <p14:creationId xmlns:p14="http://schemas.microsoft.com/office/powerpoint/2010/main" val="1333751772"/>
+      </p:ext>
+    </p:extLst>
   </p:cSld>
   <p:clrMapOvr>
     <a:masterClrMapping/>
@@ -3123,7 +3367,7 @@
 </file>
 
 <file path=ppt/slides/slide2.xml><?xml version="1.0" encoding="utf-8"?>
-<p:sld xmlns:a="http://schemas.openxmlformats.org/drawingml/2006/main" xmlns:p="http://schemas.openxmlformats.org/presentationml/2006/main" xmlns:r="http://schemas.openxmlformats.org/officeDocument/2006/relationships">
+<p:sld xmlns:a="http://schemas.openxmlformats.org/drawingml/2006/main" xmlns:r="http://schemas.openxmlformats.org/officeDocument/2006/relationships" xmlns:p="http://schemas.openxmlformats.org/presentationml/2006/main">
   <p:cSld>
     <p:spTree>
       <p:nvGrpSpPr>
@@ -3131,10 +3375,23 @@
         <p:cNvGrpSpPr/>
         <p:nvPr/>
       </p:nvGrpSpPr>
-      <p:grpSpPr/>
+      <p:grpSpPr>
+        <a:xfrm>
+          <a:off x="0" y="0"/>
+          <a:ext cx="0" cy="0"/>
+          <a:chOff x="0" y="0"/>
+          <a:chExt cx="0" cy="0"/>
+        </a:xfrm>
+      </p:grpSpPr>
       <p:pic>
         <p:nvPicPr>
-          <p:cNvPr id="2" name="Picture 1" descr="image.png"/>
+          <p:cNvPr id="5" name="Imagem 4">
+            <a:extLst>
+              <a:ext uri="{FF2B5EF4-FFF2-40B4-BE49-F238E27FC236}">
+                <a16:creationId xmlns:a16="http://schemas.microsoft.com/office/drawing/2014/main" id="{603759A7-7B5F-9064-C60F-5444E9A258E4}"/>
+              </a:ext>
+            </a:extLst>
+          </p:cNvPr>
           <p:cNvPicPr>
             <a:picLocks noChangeAspect="1"/>
           </p:cNvPicPr>
@@ -3148,8 +3405,8 @@
         </p:blipFill>
         <p:spPr>
           <a:xfrm>
-            <a:off x="0" y="0"/>
-            <a:ext cx="9144000" cy="6858000"/>
+            <a:off x="0" y="435486"/>
+            <a:ext cx="12192000" cy="3705554"/>
           </a:xfrm>
           <a:prstGeom prst="rect">
             <a:avLst/>
@@ -3157,6 +3414,11 @@
         </p:spPr>
       </p:pic>
     </p:spTree>
+    <p:extLst>
+      <p:ext uri="{BB962C8B-B14F-4D97-AF65-F5344CB8AC3E}">
+        <p14:creationId xmlns:p14="http://schemas.microsoft.com/office/powerpoint/2010/main" val="3796659829"/>
+      </p:ext>
+    </p:extLst>
   </p:cSld>
   <p:clrMapOvr>
     <a:masterClrMapping/>
@@ -3165,7 +3427,7 @@
 </file>
 
 <file path=ppt/slides/slide3.xml><?xml version="1.0" encoding="utf-8"?>
-<p:sld xmlns:a="http://schemas.openxmlformats.org/drawingml/2006/main" xmlns:p="http://schemas.openxmlformats.org/presentationml/2006/main" xmlns:r="http://schemas.openxmlformats.org/officeDocument/2006/relationships">
+<p:sld xmlns:a="http://schemas.openxmlformats.org/drawingml/2006/main" xmlns:r="http://schemas.openxmlformats.org/officeDocument/2006/relationships" xmlns:p="http://schemas.openxmlformats.org/presentationml/2006/main">
   <p:cSld>
     <p:spTree>
       <p:nvGrpSpPr>
@@ -3173,10 +3435,23 @@
         <p:cNvGrpSpPr/>
         <p:nvPr/>
       </p:nvGrpSpPr>
-      <p:grpSpPr/>
+      <p:grpSpPr>
+        <a:xfrm>
+          <a:off x="0" y="0"/>
+          <a:ext cx="0" cy="0"/>
+          <a:chOff x="0" y="0"/>
+          <a:chExt cx="0" cy="0"/>
+        </a:xfrm>
+      </p:grpSpPr>
       <p:pic>
         <p:nvPicPr>
-          <p:cNvPr id="2" name="Picture 1" descr="image.png"/>
+          <p:cNvPr id="5" name="Imagem 4">
+            <a:extLst>
+              <a:ext uri="{FF2B5EF4-FFF2-40B4-BE49-F238E27FC236}">
+                <a16:creationId xmlns:a16="http://schemas.microsoft.com/office/drawing/2014/main" id="{E15D8CEE-EFF6-43F7-EB92-F049CDC03782}"/>
+              </a:ext>
+            </a:extLst>
+          </p:cNvPr>
           <p:cNvPicPr>
             <a:picLocks noChangeAspect="1"/>
           </p:cNvPicPr>
@@ -3190,8 +3465,8 @@
         </p:blipFill>
         <p:spPr>
           <a:xfrm>
-            <a:off x="0" y="0"/>
-            <a:ext cx="9144000" cy="6858000"/>
+            <a:off x="0" y="386969"/>
+            <a:ext cx="12192000" cy="5200783"/>
           </a:xfrm>
           <a:prstGeom prst="rect">
             <a:avLst/>
@@ -3199,6 +3474,11 @@
         </p:spPr>
       </p:pic>
     </p:spTree>
+    <p:extLst>
+      <p:ext uri="{BB962C8B-B14F-4D97-AF65-F5344CB8AC3E}">
+        <p14:creationId xmlns:p14="http://schemas.microsoft.com/office/powerpoint/2010/main" val="3065455922"/>
+      </p:ext>
+    </p:extLst>
   </p:cSld>
   <p:clrMapOvr>
     <a:masterClrMapping/>
@@ -3207,7 +3487,7 @@
 </file>
 
 <file path=ppt/theme/theme1.xml><?xml version="1.0" encoding="utf-8"?>
-<a:theme xmlns:a="http://schemas.openxmlformats.org/drawingml/2006/main" name="Office Theme">
+<a:theme xmlns:a="http://schemas.openxmlformats.org/drawingml/2006/main" name="Tema do Office">
   <a:themeElements>
     <a:clrScheme name="Office">
       <a:dk1>
@@ -3217,44 +3497,44 @@
         <a:sysClr val="window" lastClr="FFFFFF"/>
       </a:lt1>
       <a:dk2>
-        <a:srgbClr val="1F497D"/>
+        <a:srgbClr val="0E2841"/>
       </a:dk2>
       <a:lt2>
-        <a:srgbClr val="EEECE1"/>
+        <a:srgbClr val="E8E8E8"/>
       </a:lt2>
       <a:accent1>
-        <a:srgbClr val="4F81BD"/>
+        <a:srgbClr val="156082"/>
       </a:accent1>
       <a:accent2>
-        <a:srgbClr val="C0504D"/>
+        <a:srgbClr val="E97132"/>
       </a:accent2>
       <a:accent3>
-        <a:srgbClr val="9BBB59"/>
+        <a:srgbClr val="196B24"/>
       </a:accent3>
       <a:accent4>
-        <a:srgbClr val="8064A2"/>
+        <a:srgbClr val="0F9ED5"/>
       </a:accent4>
       <a:accent5>
-        <a:srgbClr val="4BACC6"/>
+        <a:srgbClr val="A02B93"/>
       </a:accent5>
       <a:accent6>
-        <a:srgbClr val="F79646"/>
+        <a:srgbClr val="4EA72E"/>
       </a:accent6>
       <a:hlink>
-        <a:srgbClr val="0000FF"/>
+        <a:srgbClr val="467886"/>
       </a:hlink>
       <a:folHlink>
-        <a:srgbClr val="800080"/>
+        <a:srgbClr val="96607D"/>
       </a:folHlink>
     </a:clrScheme>
     <a:fontScheme name="Office">
       <a:majorFont>
-        <a:latin typeface="Calibri"/>
+        <a:latin typeface="Aptos Display" panose="02110004020202020204"/>
         <a:ea typeface=""/>
         <a:cs typeface=""/>
-        <a:font script="Jpan" typeface="ＭＳ Ｐゴシック"/>
+        <a:font script="Jpan" typeface="游ゴシック Light"/>
         <a:font script="Hang" typeface="맑은 고딕"/>
-        <a:font script="Hans" typeface="宋体"/>
+        <a:font script="Hans" typeface="等线 Light"/>
         <a:font script="Hant" typeface="新細明體"/>
         <a:font script="Arab" typeface="Times New Roman"/>
         <a:font script="Hebr" typeface="Times New Roman"/>
@@ -3282,14 +3562,31 @@
         <a:font script="Viet" typeface="Times New Roman"/>
         <a:font script="Uigh" typeface="Microsoft Uighur"/>
         <a:font script="Geor" typeface="Sylfaen"/>
+        <a:font script="Armn" typeface="Arial"/>
+        <a:font script="Bugi" typeface="Leelawadee UI"/>
+        <a:font script="Bopo" typeface="Microsoft JhengHei"/>
+        <a:font script="Java" typeface="Javanese Text"/>
+        <a:font script="Lisu" typeface="Segoe UI"/>
+        <a:font script="Mymr" typeface="Myanmar Text"/>
+        <a:font script="Nkoo" typeface="Ebrima"/>
+        <a:font script="Olck" typeface="Nirmala UI"/>
+        <a:font script="Osma" typeface="Ebrima"/>
+        <a:font script="Phag" typeface="Phagspa"/>
+        <a:font script="Syrn" typeface="Estrangelo Edessa"/>
+        <a:font script="Syrj" typeface="Estrangelo Edessa"/>
+        <a:font script="Syre" typeface="Estrangelo Edessa"/>
+        <a:font script="Sora" typeface="Nirmala UI"/>
+        <a:font script="Tale" typeface="Microsoft Tai Le"/>
+        <a:font script="Talu" typeface="Microsoft New Tai Lue"/>
+        <a:font script="Tfng" typeface="Ebrima"/>
       </a:majorFont>
       <a:minorFont>
-        <a:latin typeface="Calibri"/>
+        <a:latin typeface="Aptos" panose="02110004020202020204"/>
         <a:ea typeface=""/>
         <a:cs typeface=""/>
-        <a:font script="Jpan" typeface="ＭＳ Ｐゴシック"/>
+        <a:font script="Jpan" typeface="游ゴシック"/>
         <a:font script="Hang" typeface="맑은 고딕"/>
-        <a:font script="Hans" typeface="宋体"/>
+        <a:font script="Hans" typeface="等线"/>
         <a:font script="Hant" typeface="新細明體"/>
         <a:font script="Arab" typeface="Arial"/>
         <a:font script="Hebr" typeface="Arial"/>
@@ -3317,6 +3614,23 @@
         <a:font script="Viet" typeface="Arial"/>
         <a:font script="Uigh" typeface="Microsoft Uighur"/>
         <a:font script="Geor" typeface="Sylfaen"/>
+        <a:font script="Armn" typeface="Arial"/>
+        <a:font script="Bugi" typeface="Leelawadee UI"/>
+        <a:font script="Bopo" typeface="Microsoft JhengHei"/>
+        <a:font script="Java" typeface="Javanese Text"/>
+        <a:font script="Lisu" typeface="Segoe UI"/>
+        <a:font script="Mymr" typeface="Myanmar Text"/>
+        <a:font script="Nkoo" typeface="Ebrima"/>
+        <a:font script="Olck" typeface="Nirmala UI"/>
+        <a:font script="Osma" typeface="Ebrima"/>
+        <a:font script="Phag" typeface="Phagspa"/>
+        <a:font script="Syrn" typeface="Estrangelo Edessa"/>
+        <a:font script="Syrj" typeface="Estrangelo Edessa"/>
+        <a:font script="Syre" typeface="Estrangelo Edessa"/>
+        <a:font script="Sora" typeface="Nirmala UI"/>
+        <a:font script="Tale" typeface="Microsoft Tai Le"/>
+        <a:font script="Talu" typeface="Microsoft New Tai Lue"/>
+        <a:font script="Tfng" typeface="Ebrima"/>
       </a:minorFont>
     </a:fontScheme>
     <a:fmtScheme name="Office">
@@ -3328,180 +3642,136 @@
           <a:gsLst>
             <a:gs pos="0">
               <a:schemeClr val="phClr">
-                <a:tint val="50000"/>
-                <a:satMod val="300000"/>
+                <a:lumMod val="110000"/>
+                <a:satMod val="105000"/>
+                <a:tint val="67000"/>
               </a:schemeClr>
             </a:gs>
-            <a:gs pos="35000">
+            <a:gs pos="50000">
               <a:schemeClr val="phClr">
-                <a:tint val="37000"/>
-                <a:satMod val="300000"/>
+                <a:lumMod val="105000"/>
+                <a:satMod val="103000"/>
+                <a:tint val="73000"/>
               </a:schemeClr>
             </a:gs>
             <a:gs pos="100000">
               <a:schemeClr val="phClr">
-                <a:tint val="15000"/>
-                <a:satMod val="350000"/>
+                <a:lumMod val="105000"/>
+                <a:satMod val="109000"/>
+                <a:tint val="81000"/>
               </a:schemeClr>
             </a:gs>
           </a:gsLst>
-          <a:lin ang="16200000" scaled="1"/>
+          <a:lin ang="5400000" scaled="0"/>
         </a:gradFill>
         <a:gradFill rotWithShape="1">
           <a:gsLst>
             <a:gs pos="0">
               <a:schemeClr val="phClr">
-                <a:tint val="100000"/>
+                <a:satMod val="103000"/>
+                <a:lumMod val="102000"/>
+                <a:tint val="94000"/>
+              </a:schemeClr>
+            </a:gs>
+            <a:gs pos="50000">
+              <a:schemeClr val="phClr">
+                <a:satMod val="110000"/>
+                <a:lumMod val="100000"/>
                 <a:shade val="100000"/>
-                <a:satMod val="130000"/>
               </a:schemeClr>
             </a:gs>
             <a:gs pos="100000">
               <a:schemeClr val="phClr">
-                <a:tint val="50000"/>
-                <a:shade val="100000"/>
-                <a:satMod val="350000"/>
+                <a:lumMod val="99000"/>
+                <a:satMod val="120000"/>
+                <a:shade val="78000"/>
               </a:schemeClr>
             </a:gs>
           </a:gsLst>
-          <a:lin ang="16200000" scaled="0"/>
+          <a:lin ang="5400000" scaled="0"/>
         </a:gradFill>
       </a:fillStyleLst>
       <a:lnStyleLst>
-        <a:ln w="9525" cap="flat" cmpd="sng" algn="ctr">
+        <a:ln w="12700" cap="flat" cmpd="sng" algn="ctr">
           <a:solidFill>
-            <a:schemeClr val="phClr">
-              <a:shade val="95000"/>
-              <a:satMod val="105000"/>
-            </a:schemeClr>
+            <a:schemeClr val="phClr"/>
           </a:solidFill>
           <a:prstDash val="solid"/>
+          <a:miter lim="800000"/>
+        </a:ln>
+        <a:ln w="19050" cap="flat" cmpd="sng" algn="ctr">
+          <a:solidFill>
+            <a:schemeClr val="phClr"/>
+          </a:solidFill>
+          <a:prstDash val="solid"/>
+          <a:miter lim="800000"/>
         </a:ln>
         <a:ln w="25400" cap="flat" cmpd="sng" algn="ctr">
           <a:solidFill>
             <a:schemeClr val="phClr"/>
           </a:solidFill>
           <a:prstDash val="solid"/>
-        </a:ln>
-        <a:ln w="38100" cap="flat" cmpd="sng" algn="ctr">
-          <a:solidFill>
-            <a:schemeClr val="phClr"/>
-          </a:solidFill>
-          <a:prstDash val="solid"/>
+          <a:miter lim="800000"/>
         </a:ln>
       </a:lnStyleLst>
       <a:effectStyleLst>
         <a:effectStyle>
+          <a:effectLst/>
+        </a:effectStyle>
+        <a:effectStyle>
+          <a:effectLst/>
+        </a:effectStyle>
+        <a:effectStyle>
           <a:effectLst>
-            <a:outerShdw blurRad="40000" dist="20000" dir="5400000" rotWithShape="0">
+            <a:outerShdw blurRad="57150" dist="19050" dir="5400000" algn="ctr" rotWithShape="0">
               <a:srgbClr val="000000">
-                <a:alpha val="38000"/>
+                <a:alpha val="63000"/>
               </a:srgbClr>
             </a:outerShdw>
           </a:effectLst>
-        </a:effectStyle>
-        <a:effectStyle>
-          <a:effectLst>
-            <a:outerShdw blurRad="40000" dist="23000" dir="5400000" rotWithShape="0">
-              <a:srgbClr val="000000">
-                <a:alpha val="35000"/>
-              </a:srgbClr>
-            </a:outerShdw>
-          </a:effectLst>
-        </a:effectStyle>
-        <a:effectStyle>
-          <a:effectLst>
-            <a:outerShdw blurRad="40000" dist="23000" dir="5400000" rotWithShape="0">
-              <a:srgbClr val="000000">
-                <a:alpha val="35000"/>
-              </a:srgbClr>
-            </a:outerShdw>
-          </a:effectLst>
-          <a:scene3d>
-            <a:camera prst="orthographicFront">
-              <a:rot lat="0" lon="0" rev="0"/>
-            </a:camera>
-            <a:lightRig rig="threePt" dir="t">
-              <a:rot lat="0" lon="0" rev="1200000"/>
-            </a:lightRig>
-          </a:scene3d>
-          <a:sp3d>
-            <a:bevelT w="63500" h="25400"/>
-          </a:sp3d>
         </a:effectStyle>
       </a:effectStyleLst>
       <a:bgFillStyleLst>
         <a:solidFill>
           <a:schemeClr val="phClr"/>
         </a:solidFill>
+        <a:solidFill>
+          <a:schemeClr val="phClr">
+            <a:tint val="95000"/>
+            <a:satMod val="170000"/>
+          </a:schemeClr>
+        </a:solidFill>
         <a:gradFill rotWithShape="1">
           <a:gsLst>
             <a:gs pos="0">
               <a:schemeClr val="phClr">
-                <a:tint val="40000"/>
-                <a:satMod val="350000"/>
+                <a:tint val="93000"/>
+                <a:satMod val="150000"/>
+                <a:shade val="98000"/>
+                <a:lumMod val="102000"/>
               </a:schemeClr>
             </a:gs>
-            <a:gs pos="40000">
+            <a:gs pos="50000">
               <a:schemeClr val="phClr">
-                <a:tint val="45000"/>
-                <a:shade val="99000"/>
-                <a:satMod val="350000"/>
+                <a:tint val="98000"/>
+                <a:satMod val="130000"/>
+                <a:shade val="90000"/>
+                <a:lumMod val="103000"/>
               </a:schemeClr>
             </a:gs>
             <a:gs pos="100000">
               <a:schemeClr val="phClr">
-                <a:shade val="20000"/>
-                <a:satMod val="255000"/>
+                <a:shade val="63000"/>
+                <a:satMod val="120000"/>
               </a:schemeClr>
             </a:gs>
           </a:gsLst>
-          <a:path path="circle">
-            <a:fillToRect l="50000" t="-80000" r="50000" b="180000"/>
-          </a:path>
-        </a:gradFill>
-        <a:gradFill rotWithShape="1">
-          <a:gsLst>
-            <a:gs pos="0">
-              <a:schemeClr val="phClr">
-                <a:tint val="80000"/>
-                <a:satMod val="300000"/>
-              </a:schemeClr>
-            </a:gs>
-            <a:gs pos="100000">
-              <a:schemeClr val="phClr">
-                <a:shade val="30000"/>
-                <a:satMod val="200000"/>
-              </a:schemeClr>
-            </a:gs>
-          </a:gsLst>
-          <a:path path="circle">
-            <a:fillToRect l="50000" t="50000" r="50000" b="50000"/>
-          </a:path>
+          <a:lin ang="5400000" scaled="0"/>
         </a:gradFill>
       </a:bgFillStyleLst>
     </a:fmtScheme>
   </a:themeElements>
   <a:objectDefaults>
-    <a:spDef>
-      <a:spPr/>
-      <a:bodyPr/>
-      <a:lstStyle/>
-      <a:style>
-        <a:lnRef idx="1">
-          <a:schemeClr val="accent1"/>
-        </a:lnRef>
-        <a:fillRef idx="3">
-          <a:schemeClr val="accent1"/>
-        </a:fillRef>
-        <a:effectRef idx="2">
-          <a:schemeClr val="accent1"/>
-        </a:effectRef>
-        <a:fontRef idx="minor">
-          <a:schemeClr val="lt1"/>
-        </a:fontRef>
-      </a:style>
-    </a:spDef>
     <a:lnDef>
       <a:spPr/>
       <a:bodyPr/>
@@ -3523,5 +3793,10 @@
     </a:lnDef>
   </a:objectDefaults>
   <a:extraClrSchemeLst/>
+  <a:extLst>
+    <a:ext uri="{05A4C25C-085E-4340-85A3-A5531E510DB2}">
+      <thm15:themeFamily xmlns:thm15="http://schemas.microsoft.com/office/thememl/2012/main" name="Office Theme" id="{2E142A2C-CD16-42D6-873A-C26D2A0506FA}" vid="{1BDDFF52-6CD6-40A5-AB3C-68EB2F1E4D0A}"/>
+    </a:ext>
+  </a:extLst>
 </a:theme>
 </file>
</xml_diff>